<commit_message>
ci: align pipeline dependencies with project dev requirements
</commit_message>
<xml_diff>
--- a/docs/Presentation/Final_Project_Presentation.pptx
+++ b/docs/Presentation/Final_Project_Presentation.pptx
@@ -867,126 +867,90 @@
           <a:lstStyle/>
           <a:p>
             <a:r>
-              <a:t>Esta diapositiva cambió de fondo desde la versión anterior de esta defensa, y quiero</a:t>
-            </a:r>
-          </a:p>
-          <a:p>
-            <a:r>
-              <a:t>explicar exactamente qué cambió y por qué.</a:t>
+              <a:t>El patrón primario que exige el curso —ReAct más Tool Calling— está implementado, y</a:t>
+            </a:r>
+          </a:p>
+          <a:p>
+            <a:r>
+              <a:t>quiero ser explícito en esta diapositiva sobre qué significa eso exactamente: no en un solo</a:t>
+            </a:r>
+          </a:p>
+          <a:p>
+            <a:r>
+              <a:t>agente, no parcialmente — en los tres agentes especialistas: Claims, Broker Services y Commercial</a:t>
+            </a:r>
+          </a:p>
+          <a:p>
+            <a:r>
+              <a:t>Intake, todos comparten la misma instancia de ToolCallingOrchestrator.</a:t>
             </a:r>
           </a:p>
           <a:p/>
           <a:p>
             <a:r>
-              <a:t>Anteriormente presentaba ReAct como una evolución futura. Un análisis dedicado de brechas contra</a:t>
-            </a:r>
-          </a:p>
-          <a:p>
-            <a:r>
-              <a:t>el requisito del curso —ReAct más Tool Calling como patrón primario— encontró que el mecanismo ya</a:t>
-            </a:r>
-          </a:p>
-          <a:p>
-            <a:r>
-              <a:t>existía: ToolCallingOrchestrator ya implementaba un bucle acotado de Razonar, Actuar, Observar,</a:t>
-            </a:r>
-          </a:p>
-          <a:p>
-            <a:r>
-              <a:t>Razonar de nuevo, con quince pruebas que ya lo confirmaban. Lo que faltaba no era construir algo</a:t>
-            </a:r>
-          </a:p>
-          <a:p>
-            <a:r>
-              <a:t>nuevo: faltaba generalizarlo —estaba conectado solo al agente de Siniestros— y nombrarlo</a:t>
-            </a:r>
-          </a:p>
-          <a:p>
-            <a:r>
-              <a:t>explícitamente como lo que es.</a:t>
+              <a:t>El diagrama de la derecha muestra el ciclo real: el modelo razona sobre qué necesita, decide si</a:t>
+            </a:r>
+          </a:p>
+          <a:p>
+            <a:r>
+              <a:t>hace falta una herramienta, la invoca, observa el resultado, y razona de nuevo con esa</a:t>
+            </a:r>
+          </a:p>
+          <a:p>
+            <a:r>
+              <a:t>información —repitiendo el ciclo solo cuando es necesario— antes de producir su respuesta final.</a:t>
+            </a:r>
+          </a:p>
+          <a:p>
+            <a:r>
+              <a:t>Ese bucle está acotado por tres mecanismos, no solo uno: un número máximo de iteraciones,</a:t>
+            </a:r>
+          </a:p>
+          <a:p>
+            <a:r>
+              <a:t>detección de llamadas duplicadas a la misma herramienta, y un tiempo límite por llamada.</a:t>
             </a:r>
           </a:p>
           <a:p/>
           <a:p>
             <a:r>
-              <a:t>Por eso hoy ReAct más Tool Calling es el patrón primario, implementado en los tres agentes</a:t>
-            </a:r>
-          </a:p>
-          <a:p>
-            <a:r>
-              <a:t>especialistas: Claims, Broker Services y Commercial Intake. Cada uno razona internamente antes de</a:t>
-            </a:r>
-          </a:p>
-          <a:p>
-            <a:r>
-              <a:t>responder, decide si necesita una herramienta, la invoca, observa el resultado, y repite ese ciclo</a:t>
-            </a:r>
-          </a:p>
-          <a:p>
-            <a:r>
-              <a:t>solo lo necesario antes de dar su respuesta final. El Supervisor, en cambio, permanece</a:t>
-            </a:r>
-          </a:p>
-          <a:p>
-            <a:r>
-              <a:t>completamente fuera de ese bucle: sigue enrutando de forma determinista, por palabras clave, sin</a:t>
-            </a:r>
-          </a:p>
-          <a:p>
-            <a:r>
-              <a:t>ningún modelo de lenguaje involucrado — esa separación es intencional y está documentada en el</a:t>
-            </a:r>
-          </a:p>
-          <a:p>
-            <a:r>
-              <a:t>ADR-0011: el enrutamiento es una decisión de gobierno que debe ser reproducible; el razonamiento</a:t>
-            </a:r>
-          </a:p>
-          <a:p>
-            <a:r>
-              <a:t>sobre qué herramienta usar es responsabilidad de cada agente especialista.</a:t>
+              <a:t>Los patrones complementarios —Multi-Agent, Planner-Executor, Memory, Guardrails— siguen</a:t>
+            </a:r>
+          </a:p>
+          <a:p>
+            <a:r>
+              <a:t>implementados sin cambios; ReAct los complementa. Sobre RAG quiero ser honesto: la arquitectura de</a:t>
+            </a:r>
+          </a:p>
+          <a:p>
+            <a:r>
+              <a:t>Azure AI Search está disponible y lista, pero el uso actual sigue siendo con datos sintéticos —no</a:t>
+            </a:r>
+          </a:p>
+          <a:p>
+            <a:r>
+              <a:t>quiero exagerar ese punto. Y la lista de evolución futura ya no incluye ReAct: lo que queda</a:t>
+            </a:r>
+          </a:p>
+          <a:p>
+            <a:r>
+              <a:t>genúlmente sin construir es LLM-as-a-Judge y Self-Reflection.</a:t>
             </a:r>
           </a:p>
           <a:p/>
           <a:p>
             <a:r>
-              <a:t>Los patrones complementarios que ya estaban implementados —Multi-Agent, Planner-Executor, Memory,</a:t>
-            </a:r>
-          </a:p>
-          <a:p>
-            <a:r>
-              <a:t>Guardrails— siguen ahí, sin cambios; ReAct los complementa, no los reemplaza. Lo que sí cambió es</a:t>
-            </a:r>
-          </a:p>
-          <a:p>
-            <a:r>
-              <a:t>la lista de evolución futura: ya no incluye ReAct, porque dejó de ser futuro. Lo que queda son dos</a:t>
-            </a:r>
-          </a:p>
-          <a:p>
-            <a:r>
-              <a:t>patrones genuinamente no implementados — LLM-as-a-Judge y Self-Reflection — que evaluarían o</a:t>
-            </a:r>
-          </a:p>
-          <a:p>
-            <a:r>
-              <a:t>corregirían el propio razonamiento del agente, algo que este sistema no hace hoy.</a:t>
-            </a:r>
-          </a:p>
-          <a:p/>
-          <a:p>
-            <a:r>
-              <a:t>Y quiero cerrar con la regla que no cambió en absoluto: el razonamiento interno de ese bucle nunca</a:t>
-            </a:r>
-          </a:p>
-          <a:p>
-            <a:r>
-              <a:t>se expone al usuario ni se guarda en el historial de conversación — solo la respuesta final. Eso</a:t>
-            </a:r>
-          </a:p>
-          <a:p>
-            <a:r>
-              <a:t>está comprobado con pruebas dedicadas, no solo diseñado.</a:t>
+              <a:t>Cierro con la regla que gobierna todo esto: el razonamiento interno de ese bucle —cada Reason,</a:t>
+            </a:r>
+          </a:p>
+          <a:p>
+            <a:r>
+              <a:t>cada Observation— nunca se expone al usuario ni se guarda en el historial. Solo la respuesta</a:t>
+            </a:r>
+          </a:p>
+          <a:p>
+            <a:r>
+              <a:t>final. Eso está comprobado con pruebas dedicadas, no solo diseñado.</a:t>
             </a:r>
           </a:p>
         </p:txBody>
@@ -1334,1507 +1298,79 @@
           <a:lstStyle/>
           <a:p>
             <a:r>
-              <a:rPr dirty="0"/>
-              <a:t>Esta es la </a:t>
-            </a:r>
-            <a:r>
-              <a:rPr dirty="0" err="1"/>
-              <a:t>diapositiva</a:t>
-            </a:r>
-            <a:r>
-              <a:rPr dirty="0"/>
-              <a:t> central de </a:t>
-            </a:r>
-            <a:r>
-              <a:rPr dirty="0" err="1"/>
-              <a:t>toda</a:t>
-            </a:r>
-            <a:r>
-              <a:rPr dirty="0"/>
-              <a:t> la defensa, </a:t>
-            </a:r>
-            <a:r>
-              <a:rPr dirty="0" err="1"/>
-              <a:t>así</a:t>
-            </a:r>
-            <a:r>
-              <a:rPr dirty="0"/>
-              <a:t> </a:t>
-            </a:r>
-            <a:r>
-              <a:rPr dirty="0" err="1"/>
-              <a:t>que</a:t>
-            </a:r>
-            <a:r>
-              <a:rPr dirty="0"/>
-              <a:t> </a:t>
-            </a:r>
-            <a:r>
-              <a:rPr dirty="0" err="1"/>
-              <a:t>voy</a:t>
-            </a:r>
-            <a:r>
-              <a:rPr dirty="0"/>
-              <a:t> a </a:t>
-            </a:r>
-            <a:r>
-              <a:rPr dirty="0" err="1"/>
-              <a:t>recorrerla</a:t>
-            </a:r>
-            <a:r>
-              <a:rPr dirty="0"/>
-              <a:t> de </a:t>
-            </a:r>
-            <a:r>
-              <a:rPr dirty="0" err="1"/>
-              <a:t>arriba</a:t>
-            </a:r>
-            <a:r>
-              <a:rPr dirty="0"/>
-              <a:t> </a:t>
-            </a:r>
-            <a:r>
-              <a:rPr dirty="0" err="1"/>
-              <a:t>hacia</a:t>
-            </a:r>
-            <a:r>
-              <a:rPr dirty="0"/>
-              <a:t> </a:t>
-            </a:r>
-            <a:r>
-              <a:rPr dirty="0" err="1"/>
-              <a:t>abajo</a:t>
-            </a:r>
-            <a:endParaRPr dirty="0"/>
-          </a:p>
-          <a:p>
-            <a:r>
-              <a:rPr dirty="0" err="1"/>
-              <a:t>explicando</a:t>
-            </a:r>
-            <a:r>
-              <a:rPr dirty="0"/>
-              <a:t> el </a:t>
-            </a:r>
-            <a:r>
-              <a:rPr dirty="0" err="1"/>
-              <a:t>porqué</a:t>
-            </a:r>
-            <a:r>
-              <a:rPr dirty="0"/>
-              <a:t> de </a:t>
-            </a:r>
-            <a:r>
-              <a:rPr dirty="0" err="1"/>
-              <a:t>cada</a:t>
-            </a:r>
-            <a:r>
-              <a:rPr dirty="0"/>
-              <a:t> </a:t>
-            </a:r>
-            <a:r>
-              <a:rPr dirty="0" err="1"/>
-              <a:t>capa</a:t>
-            </a:r>
-            <a:r>
-              <a:rPr dirty="0"/>
-              <a:t>, no solo </a:t>
-            </a:r>
-            <a:r>
-              <a:rPr dirty="0" err="1"/>
-              <a:t>qué</a:t>
-            </a:r>
-            <a:r>
-              <a:rPr dirty="0"/>
-              <a:t> </a:t>
-            </a:r>
-            <a:r>
-              <a:rPr dirty="0" err="1"/>
-              <a:t>hace</a:t>
-            </a:r>
-            <a:r>
-              <a:rPr dirty="0"/>
-              <a:t>.</a:t>
-            </a:r>
-          </a:p>
-          <a:p>
-            <a:r>
-              <a:rPr dirty="0"/>
-              <a:t>El </a:t>
-            </a:r>
-            <a:r>
-              <a:rPr dirty="0" err="1"/>
-              <a:t>flujo</a:t>
-            </a:r>
-            <a:r>
-              <a:rPr dirty="0"/>
-              <a:t> </a:t>
-            </a:r>
-            <a:r>
-              <a:rPr dirty="0" err="1"/>
-              <a:t>empieza</a:t>
-            </a:r>
-            <a:r>
-              <a:rPr dirty="0"/>
-              <a:t> con el </a:t>
-            </a:r>
-            <a:r>
-              <a:rPr dirty="0" err="1"/>
-              <a:t>usuario</a:t>
-            </a:r>
-            <a:r>
-              <a:rPr dirty="0"/>
-              <a:t> </a:t>
-            </a:r>
-            <a:r>
-              <a:rPr dirty="0" err="1"/>
-              <a:t>autenticándose</a:t>
-            </a:r>
-            <a:r>
-              <a:rPr dirty="0"/>
-              <a:t> contra Microsoft Entra ID </a:t>
-            </a:r>
-            <a:r>
-              <a:rPr dirty="0" err="1"/>
-              <a:t>mediante</a:t>
-            </a:r>
-            <a:r>
-              <a:rPr dirty="0"/>
-              <a:t> OAuth2</a:t>
-            </a:r>
-          </a:p>
-          <a:p>
-            <a:r>
-              <a:rPr dirty="0"/>
-              <a:t>Authorization Code con PKCE — el </a:t>
-            </a:r>
-            <a:r>
-              <a:rPr dirty="0" err="1"/>
-              <a:t>flujo</a:t>
-            </a:r>
-            <a:r>
-              <a:rPr dirty="0"/>
-              <a:t> </a:t>
-            </a:r>
-            <a:r>
-              <a:rPr dirty="0" err="1"/>
-              <a:t>recomendado</a:t>
-            </a:r>
-            <a:r>
-              <a:rPr dirty="0"/>
-              <a:t> para </a:t>
-            </a:r>
-            <a:r>
-              <a:rPr dirty="0" err="1"/>
-              <a:t>una</a:t>
-            </a:r>
-            <a:r>
-              <a:rPr dirty="0"/>
-              <a:t> </a:t>
-            </a:r>
-            <a:r>
-              <a:rPr dirty="0" err="1"/>
-              <a:t>aplicación</a:t>
-            </a:r>
-            <a:r>
-              <a:rPr dirty="0"/>
-              <a:t> </a:t>
-            </a:r>
-            <a:r>
-              <a:rPr dirty="0" err="1"/>
-              <a:t>pública</a:t>
-            </a:r>
-            <a:r>
-              <a:rPr dirty="0"/>
-              <a:t> </a:t>
-            </a:r>
-            <a:r>
-              <a:rPr dirty="0" err="1"/>
-              <a:t>como</a:t>
-            </a:r>
-            <a:r>
-              <a:rPr dirty="0"/>
-              <a:t> </a:t>
-            </a:r>
-            <a:r>
-              <a:rPr dirty="0" err="1"/>
-              <a:t>esta</a:t>
-            </a:r>
-            <a:r>
-              <a:rPr dirty="0"/>
-              <a:t> SPA, </a:t>
-            </a:r>
-            <a:r>
-              <a:rPr dirty="0" err="1"/>
-              <a:t>que</a:t>
-            </a:r>
-            <a:endParaRPr dirty="0"/>
-          </a:p>
-          <a:p>
-            <a:r>
-              <a:rPr dirty="0"/>
-              <a:t>no </a:t>
-            </a:r>
-            <a:r>
-              <a:rPr dirty="0" err="1"/>
-              <a:t>puede</a:t>
-            </a:r>
-            <a:r>
-              <a:rPr dirty="0"/>
-              <a:t> </a:t>
-            </a:r>
-            <a:r>
-              <a:rPr dirty="0" err="1"/>
-              <a:t>guardar</a:t>
-            </a:r>
-            <a:r>
-              <a:rPr dirty="0"/>
-              <a:t> un </a:t>
-            </a:r>
-            <a:r>
-              <a:rPr dirty="0" err="1"/>
-              <a:t>secreto</a:t>
-            </a:r>
-            <a:r>
-              <a:rPr dirty="0"/>
-              <a:t> de </a:t>
-            </a:r>
-            <a:r>
-              <a:rPr dirty="0" err="1"/>
-              <a:t>cliente</a:t>
-            </a:r>
-            <a:r>
-              <a:rPr dirty="0"/>
-              <a:t> de forma </a:t>
-            </a:r>
-            <a:r>
-              <a:rPr dirty="0" err="1"/>
-              <a:t>segura</a:t>
-            </a:r>
-            <a:r>
-              <a:rPr dirty="0"/>
-              <a:t>. Cada </a:t>
-            </a:r>
-            <a:r>
-              <a:rPr dirty="0" err="1"/>
-              <a:t>solicitud</a:t>
-            </a:r>
-            <a:r>
-              <a:rPr dirty="0"/>
-              <a:t> </a:t>
-            </a:r>
-            <a:r>
-              <a:rPr dirty="0" err="1"/>
-              <a:t>subsiguiente</a:t>
-            </a:r>
-            <a:r>
-              <a:rPr dirty="0"/>
-              <a:t> </a:t>
-            </a:r>
-            <a:r>
-              <a:rPr dirty="0" err="1"/>
-              <a:t>llega</a:t>
-            </a:r>
-            <a:r>
-              <a:rPr dirty="0"/>
-              <a:t> a </a:t>
-            </a:r>
-            <a:r>
-              <a:rPr dirty="0" err="1"/>
-              <a:t>FastAPI</a:t>
-            </a:r>
-            <a:endParaRPr dirty="0"/>
-          </a:p>
-          <a:p>
-            <a:r>
-              <a:rPr dirty="0"/>
-              <a:t>con un token, y </a:t>
-            </a:r>
-            <a:r>
-              <a:rPr dirty="0" err="1"/>
-              <a:t>FastAPI</a:t>
-            </a:r>
-            <a:r>
-              <a:rPr dirty="0"/>
-              <a:t> lo </a:t>
-            </a:r>
-            <a:r>
-              <a:rPr dirty="0" err="1"/>
-              <a:t>valida</a:t>
-            </a:r>
-            <a:r>
-              <a:rPr dirty="0"/>
-              <a:t> </a:t>
-            </a:r>
-            <a:r>
-              <a:rPr dirty="0" err="1"/>
-              <a:t>completo</a:t>
-            </a:r>
-            <a:r>
-              <a:rPr dirty="0"/>
-              <a:t> — </a:t>
-            </a:r>
-            <a:r>
-              <a:rPr dirty="0" err="1"/>
-              <a:t>firma</a:t>
-            </a:r>
-            <a:r>
-              <a:rPr dirty="0"/>
-              <a:t>, </a:t>
-            </a:r>
-            <a:r>
-              <a:rPr dirty="0" err="1"/>
-              <a:t>expiración</a:t>
-            </a:r>
-            <a:r>
-              <a:rPr dirty="0"/>
-              <a:t>, audiencia y </a:t>
-            </a:r>
-            <a:r>
-              <a:rPr dirty="0" err="1"/>
-              <a:t>emisor</a:t>
-            </a:r>
-            <a:r>
-              <a:rPr dirty="0"/>
-              <a:t> — contra las</a:t>
-            </a:r>
-          </a:p>
-          <a:p>
-            <a:r>
-              <a:rPr dirty="0"/>
-              <a:t>claves </a:t>
-            </a:r>
-            <a:r>
-              <a:rPr dirty="0" err="1"/>
-              <a:t>públicas</a:t>
-            </a:r>
-            <a:r>
-              <a:rPr dirty="0"/>
-              <a:t> </a:t>
-            </a:r>
-            <a:r>
-              <a:rPr dirty="0" err="1"/>
-              <a:t>publicadas</a:t>
-            </a:r>
-            <a:r>
-              <a:rPr dirty="0"/>
-              <a:t> </a:t>
-            </a:r>
-            <a:r>
-              <a:rPr dirty="0" err="1"/>
-              <a:t>por</a:t>
-            </a:r>
-            <a:r>
-              <a:rPr dirty="0"/>
-              <a:t> Entra ID (JWKS). </a:t>
-            </a:r>
-            <a:r>
-              <a:rPr dirty="0" err="1"/>
-              <a:t>Ningún</a:t>
-            </a:r>
-            <a:r>
-              <a:rPr dirty="0"/>
-              <a:t> </a:t>
-            </a:r>
-            <a:r>
-              <a:rPr dirty="0" err="1"/>
-              <a:t>componente</a:t>
-            </a:r>
-            <a:r>
-              <a:rPr dirty="0"/>
-              <a:t> posterior </a:t>
-            </a:r>
-            <a:r>
-              <a:rPr dirty="0" err="1"/>
-              <a:t>vuelve</a:t>
-            </a:r>
-            <a:r>
-              <a:rPr dirty="0"/>
-              <a:t> a </a:t>
-            </a:r>
-            <a:r>
-              <a:rPr dirty="0" err="1"/>
-              <a:t>preguntar</a:t>
-            </a:r>
-            <a:endParaRPr dirty="0"/>
-          </a:p>
-          <a:p>
-            <a:r>
-              <a:rPr dirty="0" err="1"/>
-              <a:t>quién</a:t>
-            </a:r>
-            <a:r>
-              <a:rPr dirty="0"/>
-              <a:t> es el </a:t>
-            </a:r>
-            <a:r>
-              <a:rPr dirty="0" err="1"/>
-              <a:t>usuario</a:t>
-            </a:r>
-            <a:r>
-              <a:rPr dirty="0"/>
-              <a:t>: </a:t>
-            </a:r>
-            <a:r>
-              <a:rPr dirty="0" err="1"/>
-              <a:t>esa</a:t>
-            </a:r>
-            <a:r>
-              <a:rPr dirty="0"/>
-              <a:t> es la </a:t>
-            </a:r>
-            <a:r>
-              <a:rPr dirty="0" err="1"/>
-              <a:t>esencia</a:t>
-            </a:r>
-            <a:r>
-              <a:rPr dirty="0"/>
-              <a:t> de </a:t>
-            </a:r>
-            <a:r>
-              <a:rPr dirty="0" err="1"/>
-              <a:t>seguridad</a:t>
-            </a:r>
-            <a:r>
-              <a:rPr dirty="0"/>
-              <a:t> </a:t>
-            </a:r>
-            <a:r>
-              <a:rPr dirty="0" err="1"/>
-              <a:t>por</a:t>
-            </a:r>
-            <a:r>
-              <a:rPr dirty="0"/>
-              <a:t> </a:t>
-            </a:r>
-            <a:r>
-              <a:rPr dirty="0" err="1"/>
-              <a:t>diseño</a:t>
-            </a:r>
-            <a:r>
-              <a:rPr dirty="0"/>
-              <a:t> </a:t>
-            </a:r>
-            <a:r>
-              <a:rPr dirty="0" err="1"/>
-              <a:t>que</a:t>
-            </a:r>
-            <a:r>
-              <a:rPr dirty="0"/>
-              <a:t> </a:t>
-            </a:r>
-            <a:r>
-              <a:rPr dirty="0" err="1"/>
-              <a:t>mencioné</a:t>
-            </a:r>
-            <a:r>
-              <a:rPr dirty="0"/>
-              <a:t> </a:t>
-            </a:r>
-            <a:r>
-              <a:rPr dirty="0" err="1"/>
-              <a:t>en</a:t>
-            </a:r>
-            <a:r>
-              <a:rPr dirty="0"/>
-              <a:t> la </a:t>
-            </a:r>
-            <a:r>
-              <a:rPr dirty="0" err="1"/>
-              <a:t>diapositiva</a:t>
-            </a:r>
-            <a:endParaRPr dirty="0"/>
-          </a:p>
-          <a:p>
-            <a:r>
-              <a:rPr dirty="0"/>
-              <a:t>anterior.</a:t>
-            </a:r>
-          </a:p>
-          <a:p>
-            <a:r>
-              <a:rPr dirty="0"/>
-              <a:t>El Supervisor Agent </a:t>
-            </a:r>
-            <a:r>
-              <a:rPr dirty="0" err="1"/>
-              <a:t>enruta</a:t>
-            </a:r>
-            <a:r>
-              <a:rPr dirty="0"/>
-              <a:t> de forma </a:t>
-            </a:r>
-            <a:r>
-              <a:rPr dirty="0" err="1"/>
-              <a:t>determinista</a:t>
-            </a:r>
-            <a:r>
-              <a:rPr dirty="0"/>
-              <a:t> —no </a:t>
-            </a:r>
-            <a:r>
-              <a:rPr dirty="0" err="1"/>
-              <a:t>probabilística</a:t>
-            </a:r>
-            <a:r>
-              <a:rPr dirty="0"/>
-              <a:t>— </a:t>
-            </a:r>
-            <a:r>
-              <a:rPr dirty="0" err="1"/>
-              <a:t>hacia</a:t>
-            </a:r>
-            <a:r>
-              <a:rPr dirty="0"/>
-              <a:t> uno de </a:t>
-            </a:r>
-            <a:r>
-              <a:rPr dirty="0" err="1"/>
-              <a:t>los</a:t>
-            </a:r>
-            <a:r>
-              <a:rPr dirty="0"/>
-              <a:t> </a:t>
-            </a:r>
-            <a:r>
-              <a:rPr dirty="0" err="1"/>
-              <a:t>tres</a:t>
-            </a:r>
-            <a:r>
-              <a:rPr dirty="0"/>
-              <a:t> </a:t>
-            </a:r>
-            <a:r>
-              <a:rPr dirty="0" err="1"/>
-              <a:t>agentes</a:t>
-            </a:r>
-            <a:endParaRPr dirty="0"/>
-          </a:p>
-          <a:p>
-            <a:r>
-              <a:rPr dirty="0"/>
-              <a:t>de </a:t>
-            </a:r>
-            <a:r>
-              <a:rPr dirty="0" err="1"/>
-              <a:t>dominio</a:t>
-            </a:r>
-            <a:r>
-              <a:rPr dirty="0"/>
-              <a:t>, y </a:t>
-            </a:r>
-            <a:r>
-              <a:rPr dirty="0" err="1"/>
-              <a:t>cada</a:t>
-            </a:r>
-            <a:r>
-              <a:rPr dirty="0"/>
-              <a:t> </a:t>
-            </a:r>
-            <a:r>
-              <a:rPr dirty="0" err="1"/>
-              <a:t>agente</a:t>
-            </a:r>
-            <a:r>
-              <a:rPr dirty="0"/>
-              <a:t> accede a la </a:t>
-            </a:r>
-            <a:r>
-              <a:rPr dirty="0" err="1"/>
-              <a:t>lógica</a:t>
-            </a:r>
-            <a:r>
-              <a:rPr dirty="0"/>
-              <a:t> de </a:t>
-            </a:r>
-            <a:r>
-              <a:rPr dirty="0" err="1"/>
-              <a:t>negocio</a:t>
-            </a:r>
-            <a:r>
-              <a:rPr dirty="0"/>
-              <a:t> </a:t>
-            </a:r>
-            <a:r>
-              <a:rPr dirty="0" err="1"/>
-              <a:t>exclusivamente</a:t>
-            </a:r>
-            <a:r>
-              <a:rPr dirty="0"/>
-              <a:t> a </a:t>
-            </a:r>
-            <a:r>
-              <a:rPr dirty="0" err="1"/>
-              <a:t>través</a:t>
-            </a:r>
-            <a:r>
-              <a:rPr dirty="0"/>
-              <a:t> de la </a:t>
-            </a:r>
-            <a:r>
-              <a:rPr dirty="0" err="1"/>
-              <a:t>capa</a:t>
-            </a:r>
-            <a:r>
-              <a:rPr dirty="0"/>
-              <a:t> de</a:t>
-            </a:r>
-          </a:p>
-          <a:p>
-            <a:r>
-              <a:rPr dirty="0" err="1"/>
-              <a:t>herramientas</a:t>
-            </a:r>
-            <a:r>
-              <a:rPr dirty="0"/>
-              <a:t> </a:t>
-            </a:r>
-            <a:r>
-              <a:rPr dirty="0" err="1"/>
-              <a:t>determinista</a:t>
-            </a:r>
-            <a:r>
-              <a:rPr dirty="0"/>
-              <a:t>, </a:t>
-            </a:r>
-            <a:r>
-              <a:rPr dirty="0" err="1"/>
-              <a:t>nunca</a:t>
-            </a:r>
-            <a:r>
-              <a:rPr dirty="0"/>
-              <a:t> </a:t>
-            </a:r>
-            <a:r>
-              <a:rPr dirty="0" err="1"/>
-              <a:t>directamente</a:t>
-            </a:r>
-            <a:r>
-              <a:rPr dirty="0"/>
-              <a:t>. </a:t>
-            </a:r>
-            <a:r>
-              <a:rPr dirty="0" err="1"/>
-              <a:t>Aquí</a:t>
-            </a:r>
-            <a:r>
-              <a:rPr dirty="0"/>
-              <a:t> </a:t>
-            </a:r>
-            <a:r>
-              <a:rPr dirty="0" err="1"/>
-              <a:t>quiero</a:t>
-            </a:r>
-            <a:r>
-              <a:rPr dirty="0"/>
-              <a:t> ser </a:t>
-            </a:r>
-            <a:r>
-              <a:rPr dirty="0" err="1"/>
-              <a:t>explícito</a:t>
-            </a:r>
-            <a:r>
-              <a:rPr dirty="0"/>
-              <a:t> con algo </a:t>
-            </a:r>
-            <a:r>
-              <a:rPr dirty="0" err="1"/>
-              <a:t>importante</a:t>
-            </a:r>
-            <a:r>
-              <a:rPr dirty="0"/>
-              <a:t>: el</a:t>
-            </a:r>
-          </a:p>
-          <a:p>
-            <a:r>
-              <a:rPr dirty="0" err="1"/>
-              <a:t>recuadro</a:t>
-            </a:r>
-            <a:r>
-              <a:rPr dirty="0"/>
-              <a:t> de Azure Functions y Durable Functions </a:t>
-            </a:r>
-            <a:r>
-              <a:rPr dirty="0" err="1"/>
-              <a:t>tiene</a:t>
-            </a:r>
-            <a:r>
-              <a:rPr dirty="0"/>
-              <a:t> </a:t>
-            </a:r>
-            <a:r>
-              <a:rPr dirty="0" err="1"/>
-              <a:t>borde</a:t>
-            </a:r>
-            <a:r>
-              <a:rPr dirty="0"/>
-              <a:t> </a:t>
-            </a:r>
-            <a:r>
-              <a:rPr dirty="0" err="1"/>
-              <a:t>punteado</a:t>
-            </a:r>
-            <a:r>
-              <a:rPr dirty="0"/>
-              <a:t> y dice "</a:t>
-            </a:r>
-            <a:r>
-              <a:rPr dirty="0" err="1"/>
-              <a:t>arquitectura</a:t>
-            </a:r>
-            <a:endParaRPr dirty="0"/>
-          </a:p>
-          <a:p>
-            <a:r>
-              <a:rPr dirty="0" err="1"/>
-              <a:t>objetivo</a:t>
-            </a:r>
-            <a:r>
-              <a:rPr dirty="0"/>
-              <a:t>" </a:t>
-            </a:r>
-            <a:r>
-              <a:rPr dirty="0" err="1"/>
-              <a:t>porque</a:t>
-            </a:r>
-            <a:r>
-              <a:rPr dirty="0"/>
-              <a:t> no </a:t>
-            </a:r>
-            <a:r>
-              <a:rPr dirty="0" err="1"/>
-              <a:t>está</a:t>
-            </a:r>
-            <a:r>
-              <a:rPr dirty="0"/>
-              <a:t> </a:t>
-            </a:r>
-            <a:r>
-              <a:rPr dirty="0" err="1"/>
-              <a:t>desplegado</a:t>
-            </a:r>
-            <a:r>
-              <a:rPr dirty="0"/>
-              <a:t> hoy. La </a:t>
-            </a:r>
-            <a:r>
-              <a:rPr dirty="0" err="1"/>
-              <a:t>capa</a:t>
-            </a:r>
-            <a:r>
-              <a:rPr dirty="0"/>
-              <a:t> de </a:t>
-            </a:r>
-            <a:r>
-              <a:rPr dirty="0" err="1"/>
-              <a:t>herramientas</a:t>
-            </a:r>
-            <a:r>
-              <a:rPr dirty="0"/>
-              <a:t> </a:t>
-            </a:r>
-            <a:r>
-              <a:rPr dirty="0" err="1"/>
-              <a:t>sí</a:t>
-            </a:r>
-            <a:r>
-              <a:rPr dirty="0"/>
-              <a:t> </a:t>
-            </a:r>
-            <a:r>
-              <a:rPr dirty="0" err="1"/>
-              <a:t>está</a:t>
-            </a:r>
-            <a:r>
-              <a:rPr dirty="0"/>
-              <a:t> </a:t>
-            </a:r>
-            <a:r>
-              <a:rPr dirty="0" err="1"/>
-              <a:t>completamente</a:t>
-            </a:r>
-            <a:endParaRPr dirty="0"/>
-          </a:p>
-          <a:p>
-            <a:r>
-              <a:rPr dirty="0" err="1"/>
-              <a:t>diseñada</a:t>
-            </a:r>
-            <a:r>
-              <a:rPr dirty="0"/>
-              <a:t>, </a:t>
-            </a:r>
-            <a:r>
-              <a:rPr dirty="0" err="1"/>
-              <a:t>codificada</a:t>
-            </a:r>
-            <a:r>
-              <a:rPr dirty="0"/>
-              <a:t> y </a:t>
-            </a:r>
-            <a:r>
-              <a:rPr dirty="0" err="1"/>
-              <a:t>probada</a:t>
-            </a:r>
-            <a:r>
-              <a:rPr dirty="0"/>
-              <a:t> para </a:t>
-            </a:r>
-            <a:r>
-              <a:rPr dirty="0" err="1"/>
-              <a:t>ejecutarse</a:t>
-            </a:r>
-            <a:r>
-              <a:rPr dirty="0"/>
-              <a:t> ahí — </a:t>
-            </a:r>
-            <a:r>
-              <a:rPr dirty="0" err="1"/>
-              <a:t>pero</a:t>
-            </a:r>
-            <a:r>
-              <a:rPr dirty="0"/>
-              <a:t> el runtime actual, </a:t>
-            </a:r>
-            <a:r>
-              <a:rPr dirty="0" err="1"/>
-              <a:t>marcado</a:t>
-            </a:r>
-            <a:r>
-              <a:rPr dirty="0"/>
-              <a:t> </a:t>
-            </a:r>
-            <a:r>
-              <a:rPr dirty="0" err="1"/>
-              <a:t>en</a:t>
-            </a:r>
-            <a:r>
-              <a:rPr dirty="0"/>
-              <a:t> </a:t>
-            </a:r>
-            <a:r>
-              <a:rPr dirty="0" err="1"/>
-              <a:t>verde</a:t>
-            </a:r>
-            <a:r>
-              <a:rPr dirty="0"/>
-              <a:t> </a:t>
-            </a:r>
-            <a:r>
-              <a:rPr dirty="0" err="1"/>
-              <a:t>sólido</a:t>
-            </a:r>
-            <a:r>
-              <a:rPr dirty="0"/>
-              <a:t>,</a:t>
-            </a:r>
-          </a:p>
-          <a:p>
-            <a:r>
-              <a:rPr dirty="0"/>
-              <a:t>es "Tool Provider </a:t>
-            </a:r>
-            <a:r>
-              <a:rPr dirty="0" err="1"/>
-              <a:t>en</a:t>
-            </a:r>
-            <a:r>
-              <a:rPr dirty="0"/>
-              <a:t> </a:t>
-            </a:r>
-            <a:r>
-              <a:rPr dirty="0" err="1"/>
-              <a:t>proceso</a:t>
-            </a:r>
-            <a:r>
-              <a:rPr dirty="0"/>
-              <a:t>": las </a:t>
-            </a:r>
-            <a:r>
-              <a:rPr dirty="0" err="1"/>
-              <a:t>mismas</a:t>
-            </a:r>
-            <a:r>
-              <a:rPr dirty="0"/>
-              <a:t> </a:t>
-            </a:r>
-            <a:r>
-              <a:rPr dirty="0" err="1"/>
-              <a:t>herramientas</a:t>
-            </a:r>
-            <a:r>
-              <a:rPr dirty="0"/>
-              <a:t>, la </a:t>
-            </a:r>
-            <a:r>
-              <a:rPr dirty="0" err="1"/>
-              <a:t>misma</a:t>
-            </a:r>
-            <a:r>
-              <a:rPr dirty="0"/>
-              <a:t> </a:t>
-            </a:r>
-            <a:r>
-              <a:rPr dirty="0" err="1"/>
-              <a:t>lógica</a:t>
-            </a:r>
-            <a:r>
-              <a:rPr dirty="0"/>
-              <a:t> de </a:t>
-            </a:r>
-            <a:r>
-              <a:rPr dirty="0" err="1"/>
-              <a:t>negocio</a:t>
-            </a:r>
-            <a:r>
-              <a:rPr dirty="0"/>
-              <a:t>, </a:t>
-            </a:r>
-            <a:r>
-              <a:rPr dirty="0" err="1"/>
-              <a:t>ejecutando</a:t>
-            </a:r>
-            <a:endParaRPr dirty="0"/>
-          </a:p>
-          <a:p>
-            <a:r>
-              <a:rPr dirty="0" err="1"/>
-              <a:t>dentro</a:t>
-            </a:r>
-            <a:r>
-              <a:rPr dirty="0"/>
-              <a:t> del </a:t>
-            </a:r>
-            <a:r>
-              <a:rPr dirty="0" err="1"/>
-              <a:t>propio</a:t>
-            </a:r>
-            <a:r>
-              <a:rPr dirty="0"/>
-              <a:t> </a:t>
-            </a:r>
-            <a:r>
-              <a:rPr dirty="0" err="1"/>
-              <a:t>proceso</a:t>
-            </a:r>
-            <a:r>
-              <a:rPr dirty="0"/>
-              <a:t> de la API </a:t>
-            </a:r>
-            <a:r>
-              <a:rPr dirty="0" err="1"/>
-              <a:t>en</a:t>
-            </a:r>
-            <a:r>
-              <a:rPr dirty="0"/>
-              <a:t> </a:t>
-            </a:r>
-            <a:r>
-              <a:rPr dirty="0" err="1"/>
-              <a:t>lugar</a:t>
-            </a:r>
-            <a:r>
-              <a:rPr dirty="0"/>
-              <a:t> de </a:t>
-            </a:r>
-            <a:r>
-              <a:rPr dirty="0" err="1"/>
-              <a:t>en</a:t>
-            </a:r>
-            <a:r>
-              <a:rPr dirty="0"/>
-              <a:t> un endpoint serverless </a:t>
-            </a:r>
-            <a:r>
-              <a:rPr dirty="0" err="1"/>
-              <a:t>separado</a:t>
-            </a:r>
-            <a:r>
-              <a:rPr dirty="0"/>
-              <a:t>. Más </a:t>
-            </a:r>
-            <a:r>
-              <a:rPr dirty="0" err="1"/>
-              <a:t>adelante</a:t>
-            </a:r>
-            <a:endParaRPr dirty="0"/>
-          </a:p>
-          <a:p>
-            <a:r>
-              <a:rPr dirty="0" err="1"/>
-              <a:t>explico</a:t>
-            </a:r>
-            <a:r>
-              <a:rPr dirty="0"/>
-              <a:t> </a:t>
-            </a:r>
-            <a:r>
-              <a:rPr dirty="0" err="1"/>
-              <a:t>por</a:t>
-            </a:r>
-            <a:r>
-              <a:rPr dirty="0"/>
-              <a:t> </a:t>
-            </a:r>
-            <a:r>
-              <a:rPr dirty="0" err="1"/>
-              <a:t>qué</a:t>
-            </a:r>
-            <a:r>
-              <a:rPr dirty="0"/>
-              <a:t> </a:t>
-            </a:r>
-            <a:r>
-              <a:rPr dirty="0" err="1"/>
-              <a:t>exactamente</a:t>
-            </a:r>
-            <a:r>
-              <a:rPr dirty="0"/>
-              <a:t>.</a:t>
-            </a:r>
-          </a:p>
-          <a:p>
-            <a:r>
-              <a:rPr dirty="0"/>
-              <a:t>A la </a:t>
-            </a:r>
-            <a:r>
-              <a:rPr dirty="0" err="1"/>
-              <a:t>derecha</a:t>
-            </a:r>
-            <a:r>
-              <a:rPr dirty="0"/>
-              <a:t> </a:t>
-            </a:r>
-            <a:r>
-              <a:rPr dirty="0" err="1"/>
-              <a:t>están</a:t>
-            </a:r>
-            <a:r>
-              <a:rPr dirty="0"/>
-              <a:t> </a:t>
-            </a:r>
-            <a:r>
-              <a:rPr dirty="0" err="1"/>
-              <a:t>los</a:t>
-            </a:r>
-            <a:r>
-              <a:rPr dirty="0"/>
-              <a:t> </a:t>
-            </a:r>
-            <a:r>
-              <a:rPr dirty="0" err="1"/>
-              <a:t>servicios</a:t>
-            </a:r>
-            <a:r>
-              <a:rPr dirty="0"/>
-              <a:t> de IA y </a:t>
-            </a:r>
-            <a:r>
-              <a:rPr dirty="0" err="1"/>
-              <a:t>datos</a:t>
-            </a:r>
-            <a:r>
-              <a:rPr dirty="0"/>
-              <a:t>: Azure OpenAI para el </a:t>
-            </a:r>
-            <a:r>
-              <a:rPr dirty="0" err="1"/>
-              <a:t>razonamiento</a:t>
-            </a:r>
-            <a:r>
-              <a:rPr dirty="0"/>
-              <a:t> del </a:t>
-            </a:r>
-            <a:r>
-              <a:rPr dirty="0" err="1"/>
-              <a:t>modelo</a:t>
-            </a:r>
-            <a:r>
-              <a:rPr dirty="0"/>
-              <a:t>,</a:t>
-            </a:r>
-          </a:p>
-          <a:p>
-            <a:r>
-              <a:rPr dirty="0"/>
-              <a:t>Cosmos DB para el </a:t>
-            </a:r>
-            <a:r>
-              <a:rPr dirty="0" err="1"/>
-              <a:t>historial</a:t>
-            </a:r>
-            <a:r>
-              <a:rPr dirty="0"/>
-              <a:t> de </a:t>
-            </a:r>
-            <a:r>
-              <a:rPr dirty="0" err="1"/>
-              <a:t>conversación</a:t>
-            </a:r>
-            <a:r>
-              <a:rPr dirty="0"/>
-              <a:t>, y Azure AI Search —</a:t>
-            </a:r>
-            <a:r>
-              <a:rPr dirty="0" err="1"/>
-              <a:t>marcado</a:t>
-            </a:r>
-            <a:r>
-              <a:rPr dirty="0"/>
-              <a:t> </a:t>
-            </a:r>
-            <a:r>
-              <a:rPr dirty="0" err="1"/>
-              <a:t>en</a:t>
-            </a:r>
-            <a:r>
-              <a:rPr dirty="0"/>
-              <a:t> </a:t>
-            </a:r>
-            <a:r>
-              <a:rPr dirty="0" err="1"/>
-              <a:t>ámbar</a:t>
-            </a:r>
-            <a:r>
-              <a:rPr dirty="0"/>
-              <a:t> </a:t>
-            </a:r>
-            <a:r>
-              <a:rPr dirty="0" err="1"/>
-              <a:t>porque</a:t>
-            </a:r>
-            <a:r>
-              <a:rPr dirty="0"/>
-              <a:t> </a:t>
-            </a:r>
-            <a:r>
-              <a:rPr dirty="0" err="1"/>
-              <a:t>está</a:t>
-            </a:r>
-            <a:endParaRPr dirty="0"/>
-          </a:p>
-          <a:p>
-            <a:r>
-              <a:rPr dirty="0" err="1"/>
-              <a:t>provisionado</a:t>
-            </a:r>
-            <a:r>
-              <a:rPr dirty="0"/>
-              <a:t> </a:t>
-            </a:r>
-            <a:r>
-              <a:rPr dirty="0" err="1"/>
-              <a:t>pero</a:t>
-            </a:r>
-            <a:r>
-              <a:rPr dirty="0"/>
-              <a:t> </a:t>
-            </a:r>
-            <a:r>
-              <a:rPr dirty="0" err="1"/>
-              <a:t>su</a:t>
-            </a:r>
-            <a:r>
-              <a:rPr dirty="0"/>
-              <a:t> </a:t>
-            </a:r>
-            <a:r>
-              <a:rPr dirty="0" err="1"/>
-              <a:t>índice</a:t>
-            </a:r>
-            <a:r>
-              <a:rPr dirty="0"/>
-              <a:t> </a:t>
-            </a:r>
-            <a:r>
-              <a:rPr dirty="0" err="1"/>
-              <a:t>aún</a:t>
-            </a:r>
-            <a:r>
-              <a:rPr dirty="0"/>
-              <a:t> no </a:t>
-            </a:r>
-            <a:r>
-              <a:rPr dirty="0" err="1"/>
-              <a:t>está</a:t>
-            </a:r>
-            <a:r>
-              <a:rPr dirty="0"/>
-              <a:t> </a:t>
-            </a:r>
-            <a:r>
-              <a:rPr dirty="0" err="1"/>
-              <a:t>poblado</a:t>
-            </a:r>
-            <a:r>
-              <a:rPr dirty="0"/>
-              <a:t>, </a:t>
-            </a:r>
-            <a:r>
-              <a:rPr dirty="0" err="1"/>
-              <a:t>tema</a:t>
-            </a:r>
-            <a:r>
-              <a:rPr dirty="0"/>
-              <a:t> </a:t>
-            </a:r>
-            <a:r>
-              <a:rPr dirty="0" err="1"/>
-              <a:t>que</a:t>
-            </a:r>
-            <a:r>
-              <a:rPr dirty="0"/>
-              <a:t> </a:t>
-            </a:r>
-            <a:r>
-              <a:rPr dirty="0" err="1"/>
-              <a:t>profundizo</a:t>
-            </a:r>
-            <a:r>
-              <a:rPr dirty="0"/>
-              <a:t> </a:t>
-            </a:r>
-            <a:r>
-              <a:rPr dirty="0" err="1"/>
-              <a:t>en</a:t>
-            </a:r>
-            <a:r>
-              <a:rPr dirty="0"/>
-              <a:t> la </a:t>
-            </a:r>
-            <a:r>
-              <a:rPr dirty="0" err="1"/>
-              <a:t>diapositiva</a:t>
-            </a:r>
-            <a:r>
-              <a:rPr dirty="0"/>
-              <a:t> de</a:t>
-            </a:r>
-          </a:p>
-          <a:p>
-            <a:r>
-              <a:rPr dirty="0" err="1"/>
-              <a:t>arquitectura</a:t>
-            </a:r>
-            <a:r>
-              <a:rPr dirty="0"/>
-              <a:t> del </a:t>
-            </a:r>
-            <a:r>
-              <a:rPr dirty="0" err="1"/>
-              <a:t>conocimiento</a:t>
-            </a:r>
-            <a:r>
-              <a:rPr dirty="0"/>
-              <a:t>. Abajo, </a:t>
-            </a:r>
-            <a:r>
-              <a:rPr dirty="0" err="1"/>
-              <a:t>en</a:t>
-            </a:r>
-            <a:r>
-              <a:rPr dirty="0"/>
-              <a:t> la </a:t>
-            </a:r>
-            <a:r>
-              <a:rPr dirty="0" err="1"/>
-              <a:t>franja</a:t>
-            </a:r>
-            <a:r>
-              <a:rPr dirty="0"/>
-              <a:t> transversal, </a:t>
-            </a:r>
-            <a:r>
-              <a:rPr dirty="0" err="1"/>
-              <a:t>están</a:t>
-            </a:r>
-            <a:r>
-              <a:rPr dirty="0"/>
-              <a:t> </a:t>
-            </a:r>
-            <a:r>
-              <a:rPr dirty="0" err="1"/>
-              <a:t>los</a:t>
-            </a:r>
-            <a:r>
-              <a:rPr dirty="0"/>
-              <a:t> </a:t>
-            </a:r>
-            <a:r>
-              <a:rPr dirty="0" err="1"/>
-              <a:t>servicios</a:t>
-            </a:r>
-            <a:r>
-              <a:rPr dirty="0"/>
-              <a:t> de </a:t>
-            </a:r>
-            <a:r>
-              <a:rPr dirty="0" err="1"/>
-              <a:t>plataforma</a:t>
-            </a:r>
-            <a:endParaRPr dirty="0"/>
-          </a:p>
-          <a:p>
-            <a:r>
-              <a:rPr dirty="0" err="1"/>
-              <a:t>que</a:t>
-            </a:r>
-            <a:r>
-              <a:rPr dirty="0"/>
-              <a:t> no </a:t>
-            </a:r>
-            <a:r>
-              <a:rPr dirty="0" err="1"/>
-              <a:t>pertenecen</a:t>
-            </a:r>
-            <a:r>
-              <a:rPr dirty="0"/>
-              <a:t> a un paso </a:t>
-            </a:r>
-            <a:r>
-              <a:rPr dirty="0" err="1"/>
-              <a:t>específico</a:t>
-            </a:r>
-            <a:r>
-              <a:rPr dirty="0"/>
-              <a:t> del </a:t>
-            </a:r>
-            <a:r>
-              <a:rPr dirty="0" err="1"/>
-              <a:t>flujo</a:t>
-            </a:r>
-            <a:r>
-              <a:rPr dirty="0"/>
-              <a:t> </a:t>
-            </a:r>
-            <a:r>
-              <a:rPr dirty="0" err="1"/>
-              <a:t>sino</a:t>
-            </a:r>
-            <a:r>
-              <a:rPr dirty="0"/>
-              <a:t> </a:t>
-            </a:r>
-            <a:r>
-              <a:rPr dirty="0" err="1"/>
-              <a:t>que</a:t>
-            </a:r>
-            <a:r>
-              <a:rPr dirty="0"/>
-              <a:t> </a:t>
-            </a:r>
-            <a:r>
-              <a:rPr dirty="0" err="1"/>
-              <a:t>sostienen</a:t>
-            </a:r>
-            <a:r>
-              <a:rPr dirty="0"/>
-              <a:t> a </a:t>
-            </a:r>
-            <a:r>
-              <a:rPr dirty="0" err="1"/>
-              <a:t>todos</a:t>
-            </a:r>
-            <a:r>
-              <a:rPr dirty="0"/>
-              <a:t>: Container Apps y</a:t>
-            </a:r>
-          </a:p>
-          <a:p>
-            <a:r>
-              <a:rPr dirty="0"/>
-              <a:t>Container Registry para el </a:t>
-            </a:r>
-            <a:r>
-              <a:rPr dirty="0" err="1"/>
-              <a:t>despliegue</a:t>
-            </a:r>
-            <a:r>
-              <a:rPr dirty="0"/>
-              <a:t>, Key Vault y Managed Identity para la </a:t>
-            </a:r>
-            <a:r>
-              <a:rPr dirty="0" err="1"/>
-              <a:t>gestión</a:t>
-            </a:r>
-            <a:r>
-              <a:rPr dirty="0"/>
-              <a:t> de </a:t>
-            </a:r>
-            <a:r>
-              <a:rPr dirty="0" err="1"/>
-              <a:t>secretos</a:t>
-            </a:r>
-            <a:r>
-              <a:rPr dirty="0"/>
-              <a:t> e</a:t>
-            </a:r>
-          </a:p>
-          <a:p>
-            <a:r>
-              <a:rPr dirty="0" err="1"/>
-              <a:t>identidad</a:t>
-            </a:r>
-            <a:r>
-              <a:rPr dirty="0"/>
-              <a:t> de </a:t>
-            </a:r>
-            <a:r>
-              <a:rPr dirty="0" err="1"/>
-              <a:t>servicio</a:t>
-            </a:r>
-            <a:r>
-              <a:rPr dirty="0"/>
-              <a:t>, y Application Insights junto con Azure Monitor para </a:t>
-            </a:r>
-            <a:r>
-              <a:rPr dirty="0" err="1"/>
-              <a:t>observabilidad</a:t>
-            </a:r>
-            <a:r>
-              <a:rPr dirty="0"/>
-              <a:t> — </a:t>
-            </a:r>
-            <a:r>
-              <a:rPr dirty="0" err="1"/>
-              <a:t>los</a:t>
-            </a:r>
-            <a:endParaRPr dirty="0"/>
-          </a:p>
-          <a:p>
-            <a:r>
-              <a:rPr dirty="0" err="1"/>
-              <a:t>detallo</a:t>
-            </a:r>
-            <a:r>
-              <a:rPr dirty="0"/>
-              <a:t> </a:t>
-            </a:r>
-            <a:r>
-              <a:rPr dirty="0" err="1"/>
-              <a:t>en</a:t>
-            </a:r>
-            <a:r>
-              <a:rPr dirty="0"/>
-              <a:t> las </a:t>
-            </a:r>
-            <a:r>
-              <a:rPr dirty="0" err="1"/>
-              <a:t>siguientes</a:t>
-            </a:r>
-            <a:r>
-              <a:rPr dirty="0"/>
-              <a:t> </a:t>
-            </a:r>
-            <a:r>
-              <a:rPr dirty="0" err="1"/>
-              <a:t>diapositivas</a:t>
-            </a:r>
-            <a:r>
-              <a:rPr dirty="0"/>
-              <a:t>.</a:t>
+              <a:t>Esta arquitectura no cambió de forma, pero sí cambió lo que ocurre dentro de cada</a:t>
+            </a:r>
+          </a:p>
+          <a:p>
+            <a:r>
+              <a:t>agente especialista, y quiero señalarlo explícitamente en el diagrama.</a:t>
+            </a:r>
+          </a:p>
+          <a:p/>
+          <a:p>
+            <a:r>
+              <a:t>El flujo de autenticación —Entra ID, PKCE, validación JWT— es exactamente el mismo que expliqué</a:t>
+            </a:r>
+          </a:p>
+          <a:p>
+            <a:r>
+              <a:t>antes. Lo que cambió es lo que pasa después del Supervisor: el Supervisor sigue siendo</a:t>
+            </a:r>
+          </a:p>
+          <a:p>
+            <a:r>
+              <a:t>puramente determinista —enrutamiento por palabras clave, sin razonamiento de modelo alguno—, y</a:t>
+            </a:r>
+          </a:p>
+          <a:p>
+            <a:r>
+              <a:t>por eso su recuadro ahora dice explícitamente "sin ReAct". Cada uno de los tres agentes</a:t>
+            </a:r>
+          </a:p>
+          <a:p>
+            <a:r>
+              <a:t>especialistas, en cambio, ahora ejecuta un bucle ReAct acotado antes de responder —Claims, Broker</a:t>
+            </a:r>
+          </a:p>
+          <a:p>
+            <a:r>
+              <a:t>Services y Commercial Intake, los tres etiquetados "ReAct + Tool Calling" en el diagrama.</a:t>
+            </a:r>
+          </a:p>
+          <a:p/>
+          <a:p>
+            <a:r>
+              <a:t>La capa de herramientas sigue siendo la misma pieza determinista de siempre: es la única fuente</a:t>
+            </a:r>
+          </a:p>
+          <a:p>
+            <a:r>
+              <a:t>de verdad para cualquier operación de negocio, y el modelo de lenguaje nunca la ejecuta</a:t>
+            </a:r>
+          </a:p>
+          <a:p>
+            <a:r>
+              <a:t>directamente — solo puede solicitarla. Notén también que ahora nombro explícitamente el modelo,</a:t>
+            </a:r>
+          </a:p>
+          <a:p>
+            <a:r>
+              <a:t>gpt-5-mini, en el recuadro de Azure OpenAI. Y Azure Functions junto con Durable Functions siguen</a:t>
+            </a:r>
+          </a:p>
+          <a:p>
+            <a:r>
+              <a:t>marcados con borde punteado como arquitectura objetivo: el runtime actual sigue siendo Tool</a:t>
+            </a:r>
+          </a:p>
+          <a:p>
+            <a:r>
+              <a:t>Provider en proceso, exactamente como expliqué antes — eso no cambió con la generalización de</a:t>
+            </a:r>
+          </a:p>
+          <a:p>
+            <a:r>
+              <a:t>ReAct, son decisiones independientes.</a:t>
             </a:r>
           </a:p>
         </p:txBody>
@@ -15755,7 +14291,7 @@
         <p:spPr>
           <a:xfrm>
             <a:off x="1828800" y="2537460"/>
-            <a:ext cx="2011680" cy="411480"/>
+            <a:ext cx="2011680" cy="530352"/>
           </a:xfrm>
           <a:prstGeom prst="roundRect">
             <a:avLst>
@@ -15792,13 +14328,25 @@
           <a:p>
             <a:pPr algn="ctr"/>
             <a:r>
-              <a:rPr sz="1100" b="1">
+              <a:rPr sz="1050" b="1">
                 <a:solidFill>
                   <a:srgbClr val="142640"/>
                 </a:solidFill>
                 <a:latin typeface="Calibri"/>
               </a:rPr>
               <a:t>Supervisor Agent</a:t>
+            </a:r>
+          </a:p>
+          <a:p>
+            <a:pPr algn="ctr"/>
+            <a:r>
+              <a:rPr sz="750" b="0" i="1">
+                <a:solidFill>
+                  <a:srgbClr val="555555"/>
+                </a:solidFill>
+                <a:latin typeface="Calibri"/>
+              </a:rPr>
+              <a:t>Enrutamiento determinista — sin ReAct</a:t>
             </a:r>
           </a:p>
         </p:txBody>
@@ -15847,7 +14395,7 @@
         <p:spPr>
           <a:xfrm>
             <a:off x="662940" y="3131820"/>
-            <a:ext cx="1325880" cy="502920"/>
+            <a:ext cx="1325880" cy="640080"/>
           </a:xfrm>
           <a:prstGeom prst="roundRect">
             <a:avLst>
@@ -15884,14 +14432,25 @@
           <a:p>
             <a:pPr algn="ctr"/>
             <a:r>
-              <a:rPr sz="969" b="1">
+              <a:rPr sz="950" b="1">
                 <a:solidFill>
                   <a:srgbClr val="142640"/>
                 </a:solidFill>
                 <a:latin typeface="Calibri"/>
               </a:rPr>
-              <a:t>Claims
-Agent</a:t>
+              <a:t>Claims Agent</a:t>
+            </a:r>
+          </a:p>
+          <a:p>
+            <a:pPr algn="ctr"/>
+            <a:r>
+              <a:rPr sz="700" b="1" i="1">
+                <a:solidFill>
+                  <a:srgbClr val="0E7C86"/>
+                </a:solidFill>
+                <a:latin typeface="Calibri"/>
+              </a:rPr>
+              <a:t>ReAct + Tool Calling</a:t>
             </a:r>
           </a:p>
         </p:txBody>
@@ -15940,7 +14499,7 @@
         <p:spPr>
           <a:xfrm>
             <a:off x="2171700" y="3131820"/>
-            <a:ext cx="1325880" cy="502920"/>
+            <a:ext cx="1325880" cy="640080"/>
           </a:xfrm>
           <a:prstGeom prst="roundRect">
             <a:avLst>
@@ -15977,14 +14536,25 @@
           <a:p>
             <a:pPr algn="ctr"/>
             <a:r>
-              <a:rPr sz="969" b="1">
+              <a:rPr sz="950" b="1">
                 <a:solidFill>
                   <a:srgbClr val="142640"/>
                 </a:solidFill>
                 <a:latin typeface="Calibri"/>
               </a:rPr>
-              <a:t>Broker
-Agent</a:t>
+              <a:t>Broker Agent</a:t>
+            </a:r>
+          </a:p>
+          <a:p>
+            <a:pPr algn="ctr"/>
+            <a:r>
+              <a:rPr sz="700" b="1" i="1">
+                <a:solidFill>
+                  <a:srgbClr val="0E7C86"/>
+                </a:solidFill>
+                <a:latin typeface="Calibri"/>
+              </a:rPr>
+              <a:t>ReAct + Tool Calling</a:t>
             </a:r>
           </a:p>
         </p:txBody>
@@ -16033,7 +14603,7 @@
         <p:spPr>
           <a:xfrm>
             <a:off x="3680460" y="3131820"/>
-            <a:ext cx="1325880" cy="502920"/>
+            <a:ext cx="1325880" cy="640080"/>
           </a:xfrm>
           <a:prstGeom prst="roundRect">
             <a:avLst>
@@ -16070,7 +14640,7 @@
           <a:p>
             <a:pPr algn="ctr"/>
             <a:r>
-              <a:rPr sz="969" b="1">
+              <a:rPr sz="830" b="1">
                 <a:solidFill>
                   <a:srgbClr val="142640"/>
                 </a:solidFill>
@@ -16078,6 +14648,18 @@
               </a:rPr>
               <a:t>Commercial
 Intake Agent</a:t>
+            </a:r>
+          </a:p>
+          <a:p>
+            <a:pPr algn="ctr"/>
+            <a:r>
+              <a:rPr sz="700" b="1" i="1">
+                <a:solidFill>
+                  <a:srgbClr val="0E7C86"/>
+                </a:solidFill>
+                <a:latin typeface="Calibri"/>
+              </a:rPr>
+              <a:t>ReAct + Tool Calling</a:t>
             </a:r>
           </a:p>
         </p:txBody>
@@ -16126,7 +14708,7 @@
         <p:spPr>
           <a:xfrm>
             <a:off x="1463040" y="3863340"/>
-            <a:ext cx="2743200" cy="411480"/>
+            <a:ext cx="2743200" cy="530352"/>
           </a:xfrm>
           <a:prstGeom prst="roundRect">
             <a:avLst>
@@ -16163,24 +14745,37 @@
           <a:p>
             <a:pPr algn="ctr"/>
             <a:r>
-              <a:rPr sz="1080" b="1">
+              <a:rPr sz="1050" b="1">
                 <a:solidFill>
                   <a:srgbClr val="142640"/>
                 </a:solidFill>
                 <a:latin typeface="Calibri"/>
               </a:rPr>
-              <a:t>Tool Layer (determinista)</a:t>
+              <a:t>Tool Layer — determinista</a:t>
             </a:r>
           </a:p>
           <a:p>
             <a:pPr algn="ctr"/>
             <a:r>
-              <a:rPr sz="730" i="1">
+              <a:rPr sz="660" i="1">
                 <a:solidFill>
                   <a:srgbClr val="555555"/>
                 </a:solidFill>
-              </a:rPr>
-              <a:t>Runtime actual — Tool Provider = inprocess</a:t>
+                <a:latin typeface="Calibri"/>
+              </a:rPr>
+              <a:t>Fuente de verdad de negocio — el LLM nunca ejecuta la transacción</a:t>
+            </a:r>
+          </a:p>
+          <a:p>
+            <a:pPr algn="ctr"/>
+            <a:r>
+              <a:rPr sz="660" i="1">
+                <a:solidFill>
+                  <a:srgbClr val="555555"/>
+                </a:solidFill>
+                <a:latin typeface="Calibri"/>
+              </a:rPr>
+              <a:t>Runtime actual: TOOL_PROVIDER=inprocess, CLAIMS_WORKFLOW_PROVIDER=inprocess</a:t>
             </a:r>
           </a:p>
         </p:txBody>
@@ -16527,22 +15122,23 @@
           <a:p>
             <a:pPr algn="ctr"/>
             <a:r>
-              <a:rPr sz="969" b="1">
-                <a:solidFill>
-                  <a:srgbClr val="1E8A4C"/>
-                </a:solidFill>
-                <a:latin typeface="Calibri"/>
-              </a:rPr>
-              <a:t>Azure OpenAI</a:t>
+              <a:rPr sz="900" b="1">
+                <a:solidFill>
+                  <a:srgbClr val="142640"/>
+                </a:solidFill>
+                <a:latin typeface="Calibri"/>
+              </a:rPr>
+              <a:t>Azure OpenAI (gpt-5-mini)</a:t>
             </a:r>
           </a:p>
           <a:p>
             <a:pPr algn="ctr"/>
             <a:r>
-              <a:rPr sz="650" i="1">
+              <a:rPr sz="650" b="0" i="1">
                 <a:solidFill>
                   <a:srgbClr val="555555"/>
                 </a:solidFill>
+                <a:latin typeface="Calibri"/>
               </a:rPr>
               <a:t>razonamiento / tool calling</a:t>
             </a:r>
@@ -17464,7 +16060,7 @@
                 </a:solidFill>
                 <a:latin typeface="Calibri"/>
               </a:rPr>
-              <a:t>Por qué esta arquitectura, en el lenguaje de patrones del curso</a:t>
+              <a:t>El patrón primario del curso, tal como quedó implementado</a:t>
             </a:r>
           </a:p>
         </p:txBody>
@@ -17614,13 +16210,13 @@
               </a:lnSpc>
             </a:pPr>
             <a:r>
-              <a:rPr sz="830" b="0" i="1">
+              <a:rPr sz="780" b="0" i="1">
                 <a:solidFill>
                   <a:srgbClr val="555555"/>
                 </a:solidFill>
                 <a:latin typeface="Calibri"/>
               </a:rPr>
-              <a:t>Fuente: ADR-0011, src/core/tool_calling/orchestrator.py, review/06 §9</a:t>
+              <a:t>Fuente: ADR-0011, src/core/tool_calling/orchestrator.py, docs/sprint_12/validation.md</a:t>
             </a:r>
           </a:p>
         </p:txBody>
@@ -17633,8 +16229,8 @@
         </p:nvSpPr>
         <p:spPr>
           <a:xfrm>
-            <a:off x="502920" y="1051560"/>
-            <a:ext cx="11201400" cy="777240"/>
+            <a:off x="502920" y="1024128"/>
+            <a:ext cx="6446520" cy="566928"/>
           </a:xfrm>
           <a:prstGeom prst="roundRect">
             <a:avLst>
@@ -17679,8 +16275,8 @@
         </p:nvSpPr>
         <p:spPr>
           <a:xfrm>
-            <a:off x="731520" y="1133856"/>
-            <a:ext cx="10744200" cy="274320"/>
+            <a:off x="685800" y="1069848"/>
+            <a:ext cx="6080760" cy="219456"/>
           </a:xfrm>
           <a:prstGeom prst="rect">
             <a:avLst/>
@@ -17699,13 +16295,13 @@
               </a:lnSpc>
             </a:pPr>
             <a:r>
-              <a:rPr sz="1100" b="1" i="0">
+              <a:rPr sz="1000" b="1" i="0">
                 <a:solidFill>
                   <a:srgbClr val="9FC1E0"/>
                 </a:solidFill>
                 <a:latin typeface="Calibri"/>
               </a:rPr>
-              <a:t>PATRÓN PRIMARIO</a:t>
+              <a:t>PATRÓN PRINCIPAL — Status: IMPLEMENTADO</a:t>
             </a:r>
           </a:p>
         </p:txBody>
@@ -17718,8 +16314,8 @@
         </p:nvSpPr>
         <p:spPr>
           <a:xfrm>
-            <a:off x="731520" y="1371600"/>
-            <a:ext cx="10744200" cy="411480"/>
+            <a:off x="685800" y="1298448"/>
+            <a:ext cx="6080760" cy="274320"/>
           </a:xfrm>
           <a:prstGeom prst="rect">
             <a:avLst/>
@@ -17738,27 +16334,169 @@
               </a:lnSpc>
             </a:pPr>
             <a:r>
-              <a:rPr sz="1700" b="1" i="0">
+              <a:rPr sz="1450" b="1" i="0">
                 <a:solidFill>
                   <a:srgbClr val="FFFFFF"/>
                 </a:solidFill>
                 <a:latin typeface="Calibri"/>
               </a:rPr>
-              <a:t>ReAct + Tool Calling — implementado en Claims, Broker Services y Commercial Intake</a:t>
-            </a:r>
-          </a:p>
-        </p:txBody>
-      </p:sp>
-      <p:sp>
-        <p:nvSpPr>
-          <p:cNvPr id="11" name="Rounded Rectangle 10"/>
+              <a:t>✓ ReAct (Reason + Act) + Tool Calling</a:t>
+            </a:r>
+          </a:p>
+        </p:txBody>
+      </p:sp>
+      <p:sp>
+        <p:nvSpPr>
+          <p:cNvPr id="11" name="TextBox 10"/>
+          <p:cNvSpPr txBox="1"/>
+          <p:nvPr/>
+        </p:nvSpPr>
+        <p:spPr>
+          <a:xfrm>
+            <a:off x="502920" y="1691640"/>
+            <a:ext cx="6446520" cy="201168"/>
+          </a:xfrm>
+          <a:prstGeom prst="rect">
+            <a:avLst/>
+          </a:prstGeom>
+          <a:noFill/>
+        </p:spPr>
+        <p:txBody>
+          <a:bodyPr wrap="square" anchor="t" lIns="50800" rIns="50800" tIns="25400" bIns="25400">
+            <a:spAutoFit/>
+          </a:bodyPr>
+          <a:lstStyle/>
+          <a:p>
+            <a:pPr algn="l">
+              <a:lnSpc>
+                <a:spcPct val="100000"/>
+              </a:lnSpc>
+            </a:pPr>
+            <a:r>
+              <a:rPr sz="950" b="1" i="0">
+                <a:solidFill>
+                  <a:srgbClr val="0E7C86"/>
+                </a:solidFill>
+                <a:latin typeface="Calibri"/>
+              </a:rPr>
+              <a:t>IMPLEMENTACIÓN</a:t>
+            </a:r>
+          </a:p>
+        </p:txBody>
+      </p:sp>
+      <p:sp>
+        <p:nvSpPr>
+          <p:cNvPr id="12" name="TextBox 11"/>
+          <p:cNvSpPr txBox="1"/>
+          <p:nvPr/>
+        </p:nvSpPr>
+        <p:spPr>
+          <a:xfrm>
+            <a:off x="502920" y="1901952"/>
+            <a:ext cx="6446520" cy="1600200"/>
+          </a:xfrm>
+          <a:prstGeom prst="rect">
+            <a:avLst/>
+          </a:prstGeom>
+          <a:noFill/>
+        </p:spPr>
+        <p:txBody>
+          <a:bodyPr wrap="square">
+            <a:spAutoFit/>
+          </a:bodyPr>
+          <a:lstStyle/>
+          <a:p>
+            <a:pPr>
+              <a:spcAft>
+                <a:spcPts val="500"/>
+              </a:spcAft>
+            </a:pPr>
+            <a:r>
+              <a:rPr sz="969">
+                <a:solidFill>
+                  <a:srgbClr val="142640"/>
+                </a:solidFill>
+                <a:latin typeface="Calibri"/>
+              </a:rPr>
+              <a:t>▪  ToolCallingOrchestrator compartido por los tres agentes.</a:t>
+            </a:r>
+          </a:p>
+          <a:p>
+            <a:pPr>
+              <a:spcAft>
+                <a:spcPts val="500"/>
+              </a:spcAft>
+            </a:pPr>
+            <a:r>
+              <a:rPr sz="969">
+                <a:solidFill>
+                  <a:srgbClr val="142640"/>
+                </a:solidFill>
+                <a:latin typeface="Calibri"/>
+              </a:rPr>
+              <a:t>▪  Claims Agent, Broker Services Agent, Commercial Intake Agent.</a:t>
+            </a:r>
+          </a:p>
+          <a:p>
+            <a:pPr>
+              <a:spcAft>
+                <a:spcPts val="500"/>
+              </a:spcAft>
+            </a:pPr>
+            <a:r>
+              <a:rPr sz="969">
+                <a:solidFill>
+                  <a:srgbClr val="142640"/>
+                </a:solidFill>
+                <a:latin typeface="Calibri"/>
+              </a:rPr>
+              <a:t>▪  Bucle iterativo acotado, con máximo de iteraciones.</a:t>
+            </a:r>
+          </a:p>
+          <a:p>
+            <a:pPr>
+              <a:spcAft>
+                <a:spcPts val="500"/>
+              </a:spcAft>
+            </a:pPr>
+            <a:r>
+              <a:rPr sz="969">
+                <a:solidFill>
+                  <a:srgbClr val="142640"/>
+                </a:solidFill>
+                <a:latin typeface="Calibri"/>
+              </a:rPr>
+              <a:t>▪  Detección de llamadas duplicadas a herramientas.</a:t>
+            </a:r>
+          </a:p>
+          <a:p>
+            <a:pPr>
+              <a:spcAft>
+                <a:spcPts val="500"/>
+              </a:spcAft>
+            </a:pPr>
+            <a:r>
+              <a:rPr sz="969">
+                <a:solidFill>
+                  <a:srgbClr val="142640"/>
+                </a:solidFill>
+                <a:latin typeface="Calibri"/>
+              </a:rPr>
+              <a:t>▪  Protección por tiempo límite (timeout) por llamada.</a:t>
+            </a:r>
+          </a:p>
+        </p:txBody>
+      </p:sp>
+      <p:sp>
+        <p:nvSpPr>
+          <p:cNvPr id="13" name="Rounded Rectangle 12"/>
           <p:cNvSpPr/>
           <p:nvPr/>
         </p:nvSpPr>
         <p:spPr>
           <a:xfrm>
-            <a:off x="502920" y="1965960"/>
-            <a:ext cx="5532120" cy="1417320"/>
+            <a:off x="8252460" y="1545336"/>
+            <a:ext cx="2331720" cy="292608"/>
           </a:xfrm>
           <a:prstGeom prst="roundRect">
             <a:avLst>
@@ -17766,9 +16504,9 @@
             </a:avLst>
           </a:prstGeom>
           <a:solidFill>
-            <a:srgbClr val="F2F2F2"/>
+            <a:srgbClr val="FFFFFF"/>
           </a:solidFill>
-          <a:ln w="13970">
+          <a:ln w="15240">
             <a:solidFill>
               <a:srgbClr val="0E7C86"/>
             </a:solidFill>
@@ -17790,23 +16528,495 @@
           </a:fontRef>
         </p:style>
         <p:txBody>
-          <a:bodyPr rtlCol="0" anchor="ctr"/>
+          <a:bodyPr rtlCol="0" anchor="ctr" wrap="square" lIns="25400" rIns="25400" tIns="12700" bIns="12700"/>
           <a:lstStyle/>
           <a:p>
             <a:pPr algn="ctr"/>
-          </a:p>
-        </p:txBody>
-      </p:sp>
-      <p:sp>
-        <p:nvSpPr>
-          <p:cNvPr id="12" name="TextBox 11"/>
+            <a:r>
+              <a:rPr sz="869" b="1">
+                <a:solidFill>
+                  <a:srgbClr val="142640"/>
+                </a:solidFill>
+                <a:latin typeface="Calibri"/>
+              </a:rPr>
+              <a:t>Reason</a:t>
+            </a:r>
+          </a:p>
+        </p:txBody>
+      </p:sp>
+      <p:sp>
+        <p:nvSpPr>
+          <p:cNvPr id="14" name="Rounded Rectangle 13"/>
+          <p:cNvSpPr/>
+          <p:nvPr/>
+        </p:nvSpPr>
+        <p:spPr>
+          <a:xfrm>
+            <a:off x="8252460" y="1911096"/>
+            <a:ext cx="2331720" cy="292608"/>
+          </a:xfrm>
+          <a:prstGeom prst="roundRect">
+            <a:avLst>
+              <a:gd name="adj" fmla="val 6000"/>
+            </a:avLst>
+          </a:prstGeom>
+          <a:solidFill>
+            <a:srgbClr val="FFFFFF"/>
+          </a:solidFill>
+          <a:ln w="15240">
+            <a:solidFill>
+              <a:srgbClr val="0E7C86"/>
+            </a:solidFill>
+          </a:ln>
+          <a:effectLst/>
+        </p:spPr>
+        <p:style>
+          <a:lnRef idx="1">
+            <a:schemeClr val="accent1"/>
+          </a:lnRef>
+          <a:fillRef idx="3">
+            <a:schemeClr val="accent1"/>
+          </a:fillRef>
+          <a:effectRef idx="2">
+            <a:schemeClr val="accent1"/>
+          </a:effectRef>
+          <a:fontRef idx="minor">
+            <a:schemeClr val="lt1"/>
+          </a:fontRef>
+        </p:style>
+        <p:txBody>
+          <a:bodyPr rtlCol="0" anchor="ctr" wrap="square" lIns="25400" rIns="25400" tIns="12700" bIns="12700"/>
+          <a:lstStyle/>
+          <a:p>
+            <a:pPr algn="ctr"/>
+            <a:r>
+              <a:rPr sz="869" b="1">
+                <a:solidFill>
+                  <a:srgbClr val="142640"/>
+                </a:solidFill>
+                <a:latin typeface="Calibri"/>
+              </a:rPr>
+              <a:t>Action / Tool Call</a:t>
+            </a:r>
+          </a:p>
+        </p:txBody>
+      </p:sp>
+      <p:cxnSp>
+        <p:nvCxnSpPr>
+          <p:cNvPr id="15" name="Connector 14"/>
+          <p:cNvCxnSpPr/>
+          <p:nvPr/>
+        </p:nvCxnSpPr>
+        <p:spPr>
+          <a:xfrm>
+            <a:off x="9418320" y="1837944.0"/>
+            <a:ext cx="0" cy="73152.0"/>
+          </a:xfrm>
+          <a:prstGeom prst="line">
+            <a:avLst/>
+          </a:prstGeom>
+          <a:ln w="16510">
+            <a:solidFill>
+              <a:srgbClr val="0E7C86"/>
+            </a:solidFill>
+          </a:ln>
+        </p:spPr>
+        <p:style>
+          <a:lnRef idx="2">
+            <a:schemeClr val="accent1"/>
+          </a:lnRef>
+          <a:fillRef idx="0">
+            <a:schemeClr val="accent1"/>
+          </a:fillRef>
+          <a:effectRef idx="1">
+            <a:schemeClr val="accent1"/>
+          </a:effectRef>
+          <a:fontRef idx="minor">
+            <a:schemeClr val="tx1"/>
+          </a:fontRef>
+        </p:style>
+      </p:cxnSp>
+      <p:sp>
+        <p:nvSpPr>
+          <p:cNvPr id="16" name="Rounded Rectangle 15"/>
+          <p:cNvSpPr/>
+          <p:nvPr/>
+        </p:nvSpPr>
+        <p:spPr>
+          <a:xfrm>
+            <a:off x="8252460" y="2276856"/>
+            <a:ext cx="2331720" cy="292608"/>
+          </a:xfrm>
+          <a:prstGeom prst="roundRect">
+            <a:avLst>
+              <a:gd name="adj" fmla="val 6000"/>
+            </a:avLst>
+          </a:prstGeom>
+          <a:solidFill>
+            <a:srgbClr val="FFFFFF"/>
+          </a:solidFill>
+          <a:ln w="15240">
+            <a:solidFill>
+              <a:srgbClr val="0E7C86"/>
+            </a:solidFill>
+          </a:ln>
+          <a:effectLst/>
+        </p:spPr>
+        <p:style>
+          <a:lnRef idx="1">
+            <a:schemeClr val="accent1"/>
+          </a:lnRef>
+          <a:fillRef idx="3">
+            <a:schemeClr val="accent1"/>
+          </a:fillRef>
+          <a:effectRef idx="2">
+            <a:schemeClr val="accent1"/>
+          </a:effectRef>
+          <a:fontRef idx="minor">
+            <a:schemeClr val="lt1"/>
+          </a:fontRef>
+        </p:style>
+        <p:txBody>
+          <a:bodyPr rtlCol="0" anchor="ctr" wrap="square" lIns="25400" rIns="25400" tIns="12700" bIns="12700"/>
+          <a:lstStyle/>
+          <a:p>
+            <a:pPr algn="ctr"/>
+            <a:r>
+              <a:rPr sz="869" b="1">
+                <a:solidFill>
+                  <a:srgbClr val="142640"/>
+                </a:solidFill>
+                <a:latin typeface="Calibri"/>
+              </a:rPr>
+              <a:t>Observation</a:t>
+            </a:r>
+          </a:p>
+        </p:txBody>
+      </p:sp>
+      <p:cxnSp>
+        <p:nvCxnSpPr>
+          <p:cNvPr id="17" name="Connector 16"/>
+          <p:cNvCxnSpPr/>
+          <p:nvPr/>
+        </p:nvCxnSpPr>
+        <p:spPr>
+          <a:xfrm>
+            <a:off x="9418320" y="2203704.0"/>
+            <a:ext cx="0" cy="73152.0"/>
+          </a:xfrm>
+          <a:prstGeom prst="line">
+            <a:avLst/>
+          </a:prstGeom>
+          <a:ln w="16510">
+            <a:solidFill>
+              <a:srgbClr val="0E7C86"/>
+            </a:solidFill>
+          </a:ln>
+        </p:spPr>
+        <p:style>
+          <a:lnRef idx="2">
+            <a:schemeClr val="accent1"/>
+          </a:lnRef>
+          <a:fillRef idx="0">
+            <a:schemeClr val="accent1"/>
+          </a:fillRef>
+          <a:effectRef idx="1">
+            <a:schemeClr val="accent1"/>
+          </a:effectRef>
+          <a:fontRef idx="minor">
+            <a:schemeClr val="tx1"/>
+          </a:fontRef>
+        </p:style>
+      </p:cxnSp>
+      <p:sp>
+        <p:nvSpPr>
+          <p:cNvPr id="18" name="Rounded Rectangle 17"/>
+          <p:cNvSpPr/>
+          <p:nvPr/>
+        </p:nvSpPr>
+        <p:spPr>
+          <a:xfrm>
+            <a:off x="8252460" y="2642616"/>
+            <a:ext cx="2331720" cy="292608"/>
+          </a:xfrm>
+          <a:prstGeom prst="roundRect">
+            <a:avLst>
+              <a:gd name="adj" fmla="val 6000"/>
+            </a:avLst>
+          </a:prstGeom>
+          <a:solidFill>
+            <a:srgbClr val="FFFFFF"/>
+          </a:solidFill>
+          <a:ln w="15240">
+            <a:solidFill>
+              <a:srgbClr val="0E7C86"/>
+            </a:solidFill>
+          </a:ln>
+          <a:effectLst/>
+        </p:spPr>
+        <p:style>
+          <a:lnRef idx="1">
+            <a:schemeClr val="accent1"/>
+          </a:lnRef>
+          <a:fillRef idx="3">
+            <a:schemeClr val="accent1"/>
+          </a:fillRef>
+          <a:effectRef idx="2">
+            <a:schemeClr val="accent1"/>
+          </a:effectRef>
+          <a:fontRef idx="minor">
+            <a:schemeClr val="lt1"/>
+          </a:fontRef>
+        </p:style>
+        <p:txBody>
+          <a:bodyPr rtlCol="0" anchor="ctr" wrap="square" lIns="25400" rIns="25400" tIns="12700" bIns="12700"/>
+          <a:lstStyle/>
+          <a:p>
+            <a:pPr algn="ctr"/>
+            <a:r>
+              <a:rPr sz="869" b="1">
+                <a:solidFill>
+                  <a:srgbClr val="142640"/>
+                </a:solidFill>
+                <a:latin typeface="Calibri"/>
+              </a:rPr>
+              <a:t>Reason</a:t>
+            </a:r>
+          </a:p>
+        </p:txBody>
+      </p:sp>
+      <p:cxnSp>
+        <p:nvCxnSpPr>
+          <p:cNvPr id="19" name="Connector 18"/>
+          <p:cNvCxnSpPr/>
+          <p:nvPr/>
+        </p:nvCxnSpPr>
+        <p:spPr>
+          <a:xfrm>
+            <a:off x="9418320" y="2569464.0"/>
+            <a:ext cx="0" cy="73152.0"/>
+          </a:xfrm>
+          <a:prstGeom prst="line">
+            <a:avLst/>
+          </a:prstGeom>
+          <a:ln w="16510">
+            <a:solidFill>
+              <a:srgbClr val="0E7C86"/>
+            </a:solidFill>
+          </a:ln>
+        </p:spPr>
+        <p:style>
+          <a:lnRef idx="2">
+            <a:schemeClr val="accent1"/>
+          </a:lnRef>
+          <a:fillRef idx="0">
+            <a:schemeClr val="accent1"/>
+          </a:fillRef>
+          <a:effectRef idx="1">
+            <a:schemeClr val="accent1"/>
+          </a:effectRef>
+          <a:fontRef idx="minor">
+            <a:schemeClr val="tx1"/>
+          </a:fontRef>
+        </p:style>
+      </p:cxnSp>
+      <p:sp>
+        <p:nvSpPr>
+          <p:cNvPr id="20" name="Rounded Rectangle 19"/>
+          <p:cNvSpPr/>
+          <p:nvPr/>
+        </p:nvSpPr>
+        <p:spPr>
+          <a:xfrm>
+            <a:off x="8252460" y="3008376"/>
+            <a:ext cx="2331720" cy="292608"/>
+          </a:xfrm>
+          <a:prstGeom prst="roundRect">
+            <a:avLst>
+              <a:gd name="adj" fmla="val 6000"/>
+            </a:avLst>
+          </a:prstGeom>
+          <a:solidFill>
+            <a:srgbClr val="FFFFFF"/>
+          </a:solidFill>
+          <a:ln w="15240">
+            <a:solidFill>
+              <a:srgbClr val="8A8A8A"/>
+            </a:solidFill>
+            <a:prstDash val="dash"/>
+          </a:ln>
+          <a:effectLst/>
+        </p:spPr>
+        <p:style>
+          <a:lnRef idx="1">
+            <a:schemeClr val="accent1"/>
+          </a:lnRef>
+          <a:fillRef idx="3">
+            <a:schemeClr val="accent1"/>
+          </a:fillRef>
+          <a:effectRef idx="2">
+            <a:schemeClr val="accent1"/>
+          </a:effectRef>
+          <a:fontRef idx="minor">
+            <a:schemeClr val="lt1"/>
+          </a:fontRef>
+        </p:style>
+        <p:txBody>
+          <a:bodyPr rtlCol="0" anchor="ctr" wrap="square" lIns="25400" rIns="25400" tIns="12700" bIns="12700"/>
+          <a:lstStyle/>
+          <a:p>
+            <a:pPr algn="ctr"/>
+            <a:r>
+              <a:rPr sz="869" b="1">
+                <a:solidFill>
+                  <a:srgbClr val="555555"/>
+                </a:solidFill>
+                <a:latin typeface="Calibri"/>
+              </a:rPr>
+              <a:t>(Optional next Tool)</a:t>
+            </a:r>
+          </a:p>
+        </p:txBody>
+      </p:sp>
+      <p:cxnSp>
+        <p:nvCxnSpPr>
+          <p:cNvPr id="21" name="Connector 20"/>
+          <p:cNvCxnSpPr/>
+          <p:nvPr/>
+        </p:nvCxnSpPr>
+        <p:spPr>
+          <a:xfrm>
+            <a:off x="9418320" y="2935224.0"/>
+            <a:ext cx="0" cy="73152.0"/>
+          </a:xfrm>
+          <a:prstGeom prst="line">
+            <a:avLst/>
+          </a:prstGeom>
+          <a:ln w="16510">
+            <a:solidFill>
+              <a:srgbClr val="8A8A8A"/>
+            </a:solidFill>
+            <a:prstDash val="dash"/>
+          </a:ln>
+        </p:spPr>
+        <p:style>
+          <a:lnRef idx="2">
+            <a:schemeClr val="accent1"/>
+          </a:lnRef>
+          <a:fillRef idx="0">
+            <a:schemeClr val="accent1"/>
+          </a:fillRef>
+          <a:effectRef idx="1">
+            <a:schemeClr val="accent1"/>
+          </a:effectRef>
+          <a:fontRef idx="minor">
+            <a:schemeClr val="tx1"/>
+          </a:fontRef>
+        </p:style>
+      </p:cxnSp>
+      <p:sp>
+        <p:nvSpPr>
+          <p:cNvPr id="22" name="Rounded Rectangle 21"/>
+          <p:cNvSpPr/>
+          <p:nvPr/>
+        </p:nvSpPr>
+        <p:spPr>
+          <a:xfrm>
+            <a:off x="8252460" y="3374136"/>
+            <a:ext cx="2331720" cy="292608"/>
+          </a:xfrm>
+          <a:prstGeom prst="roundRect">
+            <a:avLst>
+              <a:gd name="adj" fmla="val 6000"/>
+            </a:avLst>
+          </a:prstGeom>
+          <a:solidFill>
+            <a:srgbClr val="FFFFFF"/>
+          </a:solidFill>
+          <a:ln w="15240">
+            <a:solidFill>
+              <a:srgbClr val="0E7C86"/>
+            </a:solidFill>
+          </a:ln>
+          <a:effectLst/>
+        </p:spPr>
+        <p:style>
+          <a:lnRef idx="1">
+            <a:schemeClr val="accent1"/>
+          </a:lnRef>
+          <a:fillRef idx="3">
+            <a:schemeClr val="accent1"/>
+          </a:fillRef>
+          <a:effectRef idx="2">
+            <a:schemeClr val="accent1"/>
+          </a:effectRef>
+          <a:fontRef idx="minor">
+            <a:schemeClr val="lt1"/>
+          </a:fontRef>
+        </p:style>
+        <p:txBody>
+          <a:bodyPr rtlCol="0" anchor="ctr" wrap="square" lIns="25400" rIns="25400" tIns="12700" bIns="12700"/>
+          <a:lstStyle/>
+          <a:p>
+            <a:pPr algn="ctr"/>
+            <a:r>
+              <a:rPr sz="869" b="1">
+                <a:solidFill>
+                  <a:srgbClr val="142640"/>
+                </a:solidFill>
+                <a:latin typeface="Calibri"/>
+              </a:rPr>
+              <a:t>Final Answer</a:t>
+            </a:r>
+          </a:p>
+        </p:txBody>
+      </p:sp>
+      <p:cxnSp>
+        <p:nvCxnSpPr>
+          <p:cNvPr id="23" name="Connector 22"/>
+          <p:cNvCxnSpPr/>
+          <p:nvPr/>
+        </p:nvCxnSpPr>
+        <p:spPr>
+          <a:xfrm>
+            <a:off x="9418320" y="3300984.0"/>
+            <a:ext cx="0" cy="73152.0"/>
+          </a:xfrm>
+          <a:prstGeom prst="line">
+            <a:avLst/>
+          </a:prstGeom>
+          <a:ln w="16510">
+            <a:solidFill>
+              <a:srgbClr val="8A8A8A"/>
+            </a:solidFill>
+            <a:prstDash val="dash"/>
+          </a:ln>
+        </p:spPr>
+        <p:style>
+          <a:lnRef idx="2">
+            <a:schemeClr val="accent1"/>
+          </a:lnRef>
+          <a:fillRef idx="0">
+            <a:schemeClr val="accent1"/>
+          </a:fillRef>
+          <a:effectRef idx="1">
+            <a:schemeClr val="accent1"/>
+          </a:effectRef>
+          <a:fontRef idx="minor">
+            <a:schemeClr val="tx1"/>
+          </a:fontRef>
+        </p:style>
+      </p:cxnSp>
+      <p:sp>
+        <p:nvSpPr>
+          <p:cNvPr id="24" name="TextBox 23"/>
           <p:cNvSpPr txBox="1"/>
           <p:nvPr/>
         </p:nvSpPr>
         <p:spPr>
           <a:xfrm>
-            <a:off x="685800" y="2057400"/>
-            <a:ext cx="5166360" cy="274320"/>
+            <a:off x="502920" y="3657600"/>
+            <a:ext cx="11201400" cy="219456"/>
           </a:xfrm>
           <a:prstGeom prst="rect">
             <a:avLst/>
@@ -17825,82 +17035,27 @@
               </a:lnSpc>
             </a:pPr>
             <a:r>
-              <a:rPr sz="1250" b="1" i="0">
-                <a:solidFill>
-                  <a:srgbClr val="0E7C86"/>
-                </a:solidFill>
-                <a:latin typeface="Calibri"/>
-              </a:rPr>
-              <a:t>Supervisor Agent</a:t>
-            </a:r>
-          </a:p>
-        </p:txBody>
-      </p:sp>
-      <p:sp>
-        <p:nvSpPr>
-          <p:cNvPr id="13" name="TextBox 12"/>
-          <p:cNvSpPr txBox="1"/>
-          <p:nvPr/>
-        </p:nvSpPr>
-        <p:spPr>
-          <a:xfrm>
-            <a:off x="685800" y="2359152"/>
-            <a:ext cx="5166360" cy="960120"/>
-          </a:xfrm>
-          <a:prstGeom prst="rect">
-            <a:avLst/>
-          </a:prstGeom>
-          <a:noFill/>
-        </p:spPr>
-        <p:txBody>
-          <a:bodyPr wrap="square">
-            <a:spAutoFit/>
-          </a:bodyPr>
-          <a:lstStyle/>
-          <a:p>
-            <a:pPr>
-              <a:spcAft>
-                <a:spcPts val="600"/>
-              </a:spcAft>
-            </a:pPr>
-            <a:r>
-              <a:rPr sz="1100">
-                <a:solidFill>
-                  <a:srgbClr val="142640"/>
-                </a:solidFill>
-                <a:latin typeface="Calibri"/>
-              </a:rPr>
-              <a:t>▪  Orquestación determinista — enrutamiento por palabras clave, sin LLM.</a:t>
-            </a:r>
-          </a:p>
-          <a:p>
-            <a:pPr>
-              <a:spcAft>
-                <a:spcPts val="600"/>
-              </a:spcAft>
-            </a:pPr>
-            <a:r>
-              <a:rPr sz="1100">
-                <a:solidFill>
-                  <a:srgbClr val="142640"/>
-                </a:solidFill>
-                <a:latin typeface="Calibri"/>
-              </a:rPr>
-              <a:t>▪  Permanece fuera del bucle ReAct por diseño (ADR-0011).</a:t>
-            </a:r>
-          </a:p>
-        </p:txBody>
-      </p:sp>
-      <p:sp>
-        <p:nvSpPr>
-          <p:cNvPr id="14" name="Rounded Rectangle 13"/>
+              <a:rPr sz="1050" b="1" i="0">
+                <a:solidFill>
+                  <a:srgbClr val="1F3A5F"/>
+                </a:solidFill>
+                <a:latin typeface="Calibri"/>
+              </a:rPr>
+              <a:t>PATRONES COMPLEMENTARIOS</a:t>
+            </a:r>
+          </a:p>
+        </p:txBody>
+      </p:sp>
+      <p:sp>
+        <p:nvSpPr>
+          <p:cNvPr id="25" name="Rounded Rectangle 24"/>
           <p:cNvSpPr/>
           <p:nvPr/>
         </p:nvSpPr>
         <p:spPr>
           <a:xfrm>
-            <a:off x="6172200" y="1965960"/>
-            <a:ext cx="5532120" cy="1417320"/>
+            <a:off x="502920" y="3913632"/>
+            <a:ext cx="2743200" cy="749808"/>
           </a:xfrm>
           <a:prstGeom prst="roundRect">
             <a:avLst>
@@ -17910,9 +17065,9 @@
           <a:solidFill>
             <a:srgbClr val="F2F2F2"/>
           </a:solidFill>
-          <a:ln w="13970">
+          <a:ln w="12700">
             <a:solidFill>
-              <a:srgbClr val="0E7C86"/>
+              <a:srgbClr val="1E8A4C"/>
             </a:solidFill>
           </a:ln>
           <a:effectLst/>
@@ -17941,14 +17096,14 @@
       </p:sp>
       <p:sp>
         <p:nvSpPr>
-          <p:cNvPr id="15" name="TextBox 14"/>
+          <p:cNvPr id="26" name="TextBox 25"/>
           <p:cNvSpPr txBox="1"/>
           <p:nvPr/>
         </p:nvSpPr>
         <p:spPr>
           <a:xfrm>
-            <a:off x="6355080" y="2057400"/>
-            <a:ext cx="5166360" cy="274320"/>
+            <a:off x="612648" y="3959352"/>
+            <a:ext cx="2523744" cy="237744"/>
           </a:xfrm>
           <a:prstGeom prst="rect">
             <a:avLst/>
@@ -17967,82 +17122,27 @@
               </a:lnSpc>
             </a:pPr>
             <a:r>
-              <a:rPr sz="1250" b="1" i="0">
-                <a:solidFill>
-                  <a:srgbClr val="0E7C86"/>
-                </a:solidFill>
-                <a:latin typeface="Calibri"/>
-              </a:rPr>
-              <a:t>Agentes Especialistas</a:t>
-            </a:r>
-          </a:p>
-        </p:txBody>
-      </p:sp>
-      <p:sp>
-        <p:nvSpPr>
-          <p:cNvPr id="16" name="TextBox 15"/>
+              <a:rPr sz="1050" b="1" i="0">
+                <a:solidFill>
+                  <a:srgbClr val="1E8A4C"/>
+                </a:solidFill>
+                <a:latin typeface="Calibri"/>
+              </a:rPr>
+              <a:t>✓ Multi-Agent</a:t>
+            </a:r>
+          </a:p>
+        </p:txBody>
+      </p:sp>
+      <p:sp>
+        <p:nvSpPr>
+          <p:cNvPr id="27" name="TextBox 26"/>
           <p:cNvSpPr txBox="1"/>
           <p:nvPr/>
         </p:nvSpPr>
         <p:spPr>
           <a:xfrm>
-            <a:off x="6355080" y="2359152"/>
-            <a:ext cx="5166360" cy="960120"/>
-          </a:xfrm>
-          <a:prstGeom prst="rect">
-            <a:avLst/>
-          </a:prstGeom>
-          <a:noFill/>
-        </p:spPr>
-        <p:txBody>
-          <a:bodyPr wrap="square">
-            <a:spAutoFit/>
-          </a:bodyPr>
-          <a:lstStyle/>
-          <a:p>
-            <a:pPr>
-              <a:spcAft>
-                <a:spcPts val="600"/>
-              </a:spcAft>
-            </a:pPr>
-            <a:r>
-              <a:rPr sz="1100">
-                <a:solidFill>
-                  <a:srgbClr val="142640"/>
-                </a:solidFill>
-                <a:latin typeface="Calibri"/>
-              </a:rPr>
-              <a:t>▪  Claims, Broker Services y Commercial Intake ejecutan el bucle ReAct.</a:t>
-            </a:r>
-          </a:p>
-          <a:p>
-            <a:pPr>
-              <a:spcAft>
-                <a:spcPts val="600"/>
-              </a:spcAft>
-            </a:pPr>
-            <a:r>
-              <a:rPr sz="1100">
-                <a:solidFill>
-                  <a:srgbClr val="142640"/>
-                </a:solidFill>
-                <a:latin typeface="Calibri"/>
-              </a:rPr>
-              <a:t>▪  Reason → Action (Tool) → Observation → Reason → ... → Final Answer.</a:t>
-            </a:r>
-          </a:p>
-        </p:txBody>
-      </p:sp>
-      <p:sp>
-        <p:nvSpPr>
-          <p:cNvPr id="17" name="TextBox 16"/>
-          <p:cNvSpPr txBox="1"/>
-          <p:nvPr/>
-        </p:nvSpPr>
-        <p:spPr>
-          <a:xfrm>
-            <a:off x="502920" y="3520440"/>
-            <a:ext cx="5486400" cy="228600"/>
+            <a:off x="612648" y="4206240"/>
+            <a:ext cx="2523744" cy="420624"/>
           </a:xfrm>
           <a:prstGeom prst="rect">
             <a:avLst/>
@@ -18061,444 +17161,27 @@
               </a:lnSpc>
             </a:pPr>
             <a:r>
-              <a:rPr sz="1100" b="1" i="0">
-                <a:solidFill>
-                  <a:srgbClr val="1F3A5F"/>
-                </a:solidFill>
-                <a:latin typeface="Calibri"/>
-              </a:rPr>
-              <a:t>PATRONES COMPLEMENTARIOS YA IMPLEMENTADOS</a:t>
-            </a:r>
-          </a:p>
-        </p:txBody>
-      </p:sp>
-      <p:graphicFrame>
-        <p:nvGraphicFramePr>
-          <p:cNvPr id="18" name="Table 17"/>
-          <p:cNvGraphicFramePr>
-            <a:graphicFrameLocks noGrp="1"/>
-          </p:cNvGraphicFramePr>
-          <p:nvPr/>
-        </p:nvGraphicFramePr>
-        <p:xfrm>
-          <a:off x="502920" y="3794760"/>
-          <a:ext cx="11201400" cy="1691640"/>
-        </p:xfrm>
-        <a:graphic>
-          <a:graphicData uri="http://schemas.openxmlformats.org/drawingml/2006/table">
-            <a:tbl>
-              <a:tblPr firstRow="1" bandRow="1">
-                <a:tableStyleId>{5C22544A-7EE6-4342-B048-85BDC9FD1C3A}</a:tableStyleId>
-              </a:tblPr>
-              <a:tblGrid>
-                <a:gridCol w="2103120"/>
-                <a:gridCol w="7178040"/>
-                <a:gridCol w="1920240"/>
-              </a:tblGrid>
-              <a:tr h="281940">
-                <a:tc>
-                  <a:txBody>
-                    <a:bodyPr/>
-                    <a:lstStyle/>
-                    <a:p>
-                      <a:r>
-                        <a:rPr b="1" sz="1050">
-                          <a:solidFill>
-                            <a:srgbClr val="FFFFFF"/>
-                          </a:solidFill>
-                        </a:rPr>
-                        <a:t>Patrón</a:t>
-                      </a:r>
-                    </a:p>
-                  </a:txBody>
-                  <a:tcPr anchor="ctr" marL="50800" marR="50800">
-                    <a:solidFill>
-                      <a:srgbClr val="1F3A5F"/>
-                    </a:solidFill>
-                  </a:tcPr>
-                </a:tc>
-                <a:tc>
-                  <a:txBody>
-                    <a:bodyPr/>
-                    <a:lstStyle/>
-                    <a:p>
-                      <a:r>
-                        <a:rPr b="1" sz="1050">
-                          <a:solidFill>
-                            <a:srgbClr val="FFFFFF"/>
-                          </a:solidFill>
-                        </a:rPr>
-                        <a:t>Cómo se implementa</a:t>
-                      </a:r>
-                    </a:p>
-                  </a:txBody>
-                  <a:tcPr anchor="ctr" marL="50800" marR="50800">
-                    <a:solidFill>
-                      <a:srgbClr val="1F3A5F"/>
-                    </a:solidFill>
-                  </a:tcPr>
-                </a:tc>
-                <a:tc>
-                  <a:txBody>
-                    <a:bodyPr/>
-                    <a:lstStyle/>
-                    <a:p>
-                      <a:r>
-                        <a:rPr b="1" sz="1050">
-                          <a:solidFill>
-                            <a:srgbClr val="FFFFFF"/>
-                          </a:solidFill>
-                        </a:rPr>
-                        <a:t>Estado</a:t>
-                      </a:r>
-                    </a:p>
-                  </a:txBody>
-                  <a:tcPr anchor="ctr" marL="50800" marR="50800">
-                    <a:solidFill>
-                      <a:srgbClr val="1F3A5F"/>
-                    </a:solidFill>
-                  </a:tcPr>
-                </a:tc>
-              </a:tr>
-              <a:tr h="281940">
-                <a:tc>
-                  <a:txBody>
-                    <a:bodyPr wrap="square"/>
-                    <a:lstStyle/>
-                    <a:p>
-                      <a:r>
-                        <a:rPr sz="969">
-                          <a:solidFill>
-                            <a:srgbClr val="142640"/>
-                          </a:solidFill>
-                        </a:rPr>
-                        <a:t>Multi-Agent</a:t>
-                      </a:r>
-                    </a:p>
-                  </a:txBody>
-                  <a:tcPr anchor="ctr" marL="50800" marR="50800">
-                    <a:solidFill>
-                      <a:srgbClr val="FFFFFF"/>
-                    </a:solidFill>
-                  </a:tcPr>
-                </a:tc>
-                <a:tc>
-                  <a:txBody>
-                    <a:bodyPr wrap="square"/>
-                    <a:lstStyle/>
-                    <a:p>
-                      <a:r>
-                        <a:rPr sz="969">
-                          <a:solidFill>
-                            <a:srgbClr val="142640"/>
-                          </a:solidFill>
-                        </a:rPr>
-                        <a:t>Supervisor + Claims Agent + Broker Agent + Commercial Intake Agent</a:t>
-                      </a:r>
-                    </a:p>
-                  </a:txBody>
-                  <a:tcPr anchor="ctr" marL="50800" marR="50800">
-                    <a:solidFill>
-                      <a:srgbClr val="FFFFFF"/>
-                    </a:solidFill>
-                  </a:tcPr>
-                </a:tc>
-                <a:tc>
-                  <a:txBody>
-                    <a:bodyPr wrap="square"/>
-                    <a:lstStyle/>
-                    <a:p>
-                      <a:r>
-                        <a:rPr sz="969">
-                          <a:solidFill>
-                            <a:srgbClr val="142640"/>
-                          </a:solidFill>
-                        </a:rPr>
-                        <a:t>Implementado</a:t>
-                      </a:r>
-                    </a:p>
-                  </a:txBody>
-                  <a:tcPr anchor="ctr" marL="50800" marR="50800">
-                    <a:solidFill>
-                      <a:srgbClr val="FFFFFF"/>
-                    </a:solidFill>
-                  </a:tcPr>
-                </a:tc>
-              </a:tr>
-              <a:tr h="281940">
-                <a:tc>
-                  <a:txBody>
-                    <a:bodyPr wrap="square"/>
-                    <a:lstStyle/>
-                    <a:p>
-                      <a:r>
-                        <a:rPr sz="969">
-                          <a:solidFill>
-                            <a:srgbClr val="142640"/>
-                          </a:solidFill>
-                        </a:rPr>
-                        <a:t>Planner–Executor</a:t>
-                      </a:r>
-                    </a:p>
-                  </a:txBody>
-                  <a:tcPr anchor="ctr" marL="50800" marR="50800">
-                    <a:solidFill>
-                      <a:srgbClr val="F2F2F2"/>
-                    </a:solidFill>
-                  </a:tcPr>
-                </a:tc>
-                <a:tc>
-                  <a:txBody>
-                    <a:bodyPr wrap="square"/>
-                    <a:lstStyle/>
-                    <a:p>
-                      <a:r>
-                        <a:rPr sz="969">
-                          <a:solidFill>
-                            <a:srgbClr val="142640"/>
-                          </a:solidFill>
-                        </a:rPr>
-                        <a:t>El Supervisor enruta (planifica); cada agente especialista ejecuta</a:t>
-                      </a:r>
-                    </a:p>
-                  </a:txBody>
-                  <a:tcPr anchor="ctr" marL="50800" marR="50800">
-                    <a:solidFill>
-                      <a:srgbClr val="F2F2F2"/>
-                    </a:solidFill>
-                  </a:tcPr>
-                </a:tc>
-                <a:tc>
-                  <a:txBody>
-                    <a:bodyPr wrap="square"/>
-                    <a:lstStyle/>
-                    <a:p>
-                      <a:r>
-                        <a:rPr sz="969">
-                          <a:solidFill>
-                            <a:srgbClr val="142640"/>
-                          </a:solidFill>
-                        </a:rPr>
-                        <a:t>Implementado</a:t>
-                      </a:r>
-                    </a:p>
-                  </a:txBody>
-                  <a:tcPr anchor="ctr" marL="50800" marR="50800">
-                    <a:solidFill>
-                      <a:srgbClr val="F2F2F2"/>
-                    </a:solidFill>
-                  </a:tcPr>
-                </a:tc>
-              </a:tr>
-              <a:tr h="281940">
-                <a:tc>
-                  <a:txBody>
-                    <a:bodyPr wrap="square"/>
-                    <a:lstStyle/>
-                    <a:p>
-                      <a:r>
-                        <a:rPr sz="969">
-                          <a:solidFill>
-                            <a:srgbClr val="142640"/>
-                          </a:solidFill>
-                        </a:rPr>
-                        <a:t>Memory</a:t>
-                      </a:r>
-                    </a:p>
-                  </a:txBody>
-                  <a:tcPr anchor="ctr" marL="50800" marR="50800">
-                    <a:solidFill>
-                      <a:srgbClr val="FFFFFF"/>
-                    </a:solidFill>
-                  </a:tcPr>
-                </a:tc>
-                <a:tc>
-                  <a:txBody>
-                    <a:bodyPr wrap="square"/>
-                    <a:lstStyle/>
-                    <a:p>
-                      <a:r>
-                        <a:rPr sz="969">
-                          <a:solidFill>
-                            <a:srgbClr val="142640"/>
-                          </a:solidFill>
-                        </a:rPr>
-                        <a:t>Memoria conversacional en Cosmos DB, entre dominios</a:t>
-                      </a:r>
-                    </a:p>
-                  </a:txBody>
-                  <a:tcPr anchor="ctr" marL="50800" marR="50800">
-                    <a:solidFill>
-                      <a:srgbClr val="FFFFFF"/>
-                    </a:solidFill>
-                  </a:tcPr>
-                </a:tc>
-                <a:tc>
-                  <a:txBody>
-                    <a:bodyPr wrap="square"/>
-                    <a:lstStyle/>
-                    <a:p>
-                      <a:r>
-                        <a:rPr sz="969">
-                          <a:solidFill>
-                            <a:srgbClr val="142640"/>
-                          </a:solidFill>
-                        </a:rPr>
-                        <a:t>Implementado</a:t>
-                      </a:r>
-                    </a:p>
-                  </a:txBody>
-                  <a:tcPr anchor="ctr" marL="50800" marR="50800">
-                    <a:solidFill>
-                      <a:srgbClr val="FFFFFF"/>
-                    </a:solidFill>
-                  </a:tcPr>
-                </a:tc>
-              </a:tr>
-              <a:tr h="281940">
-                <a:tc>
-                  <a:txBody>
-                    <a:bodyPr wrap="square"/>
-                    <a:lstStyle/>
-                    <a:p>
-                      <a:r>
-                        <a:rPr sz="969">
-                          <a:solidFill>
-                            <a:srgbClr val="142640"/>
-                          </a:solidFill>
-                        </a:rPr>
-                        <a:t>Guardrails</a:t>
-                      </a:r>
-                    </a:p>
-                  </a:txBody>
-                  <a:tcPr anchor="ctr" marL="50800" marR="50800">
-                    <a:solidFill>
-                      <a:srgbClr val="F2F2F2"/>
-                    </a:solidFill>
-                  </a:tcPr>
-                </a:tc>
-                <a:tc>
-                  <a:txBody>
-                    <a:bodyPr wrap="square"/>
-                    <a:lstStyle/>
-                    <a:p>
-                      <a:r>
-                        <a:rPr sz="969">
-                          <a:solidFill>
-                            <a:srgbClr val="142640"/>
-                          </a:solidFill>
-                        </a:rPr>
-                        <a:t>Entra ID + JWT/JWKS + Tool Calling determinista</a:t>
-                      </a:r>
-                    </a:p>
-                  </a:txBody>
-                  <a:tcPr anchor="ctr" marL="50800" marR="50800">
-                    <a:solidFill>
-                      <a:srgbClr val="F2F2F2"/>
-                    </a:solidFill>
-                  </a:tcPr>
-                </a:tc>
-                <a:tc>
-                  <a:txBody>
-                    <a:bodyPr wrap="square"/>
-                    <a:lstStyle/>
-                    <a:p>
-                      <a:r>
-                        <a:rPr sz="969">
-                          <a:solidFill>
-                            <a:srgbClr val="142640"/>
-                          </a:solidFill>
-                        </a:rPr>
-                        <a:t>Implementado</a:t>
-                      </a:r>
-                    </a:p>
-                  </a:txBody>
-                  <a:tcPr anchor="ctr" marL="50800" marR="50800">
-                    <a:solidFill>
-                      <a:srgbClr val="F2F2F2"/>
-                    </a:solidFill>
-                  </a:tcPr>
-                </a:tc>
-              </a:tr>
-              <a:tr h="281940">
-                <a:tc>
-                  <a:txBody>
-                    <a:bodyPr wrap="square"/>
-                    <a:lstStyle/>
-                    <a:p>
-                      <a:r>
-                        <a:rPr sz="969">
-                          <a:solidFill>
-                            <a:srgbClr val="142640"/>
-                          </a:solidFill>
-                        </a:rPr>
-                        <a:t>RAG</a:t>
-                      </a:r>
-                    </a:p>
-                  </a:txBody>
-                  <a:tcPr anchor="ctr" marL="50800" marR="50800">
-                    <a:solidFill>
-                      <a:srgbClr val="FFFFFF"/>
-                    </a:solidFill>
-                  </a:tcPr>
-                </a:tc>
-                <a:tc>
-                  <a:txBody>
-                    <a:bodyPr wrap="square"/>
-                    <a:lstStyle/>
-                    <a:p>
-                      <a:r>
-                        <a:rPr sz="969">
-                          <a:solidFill>
-                            <a:srgbClr val="142640"/>
-                          </a:solidFill>
-                        </a:rPr>
-                        <a:t>Azure AI Search integrado; hoy con datos sintéticos</a:t>
-                      </a:r>
-                    </a:p>
-                  </a:txBody>
-                  <a:tcPr anchor="ctr" marL="50800" marR="50800">
-                    <a:solidFill>
-                      <a:srgbClr val="FFFFFF"/>
-                    </a:solidFill>
-                  </a:tcPr>
-                </a:tc>
-                <a:tc>
-                  <a:txBody>
-                    <a:bodyPr wrap="square"/>
-                    <a:lstStyle/>
-                    <a:p>
-                      <a:r>
-                        <a:rPr sz="969">
-                          <a:solidFill>
-                            <a:srgbClr val="142640"/>
-                          </a:solidFill>
-                        </a:rPr>
-                        <a:t>Arquitectura lista</a:t>
-                      </a:r>
-                    </a:p>
-                  </a:txBody>
-                  <a:tcPr anchor="ctr" marL="50800" marR="50800">
-                    <a:solidFill>
-                      <a:srgbClr val="FFFFFF"/>
-                    </a:solidFill>
-                  </a:tcPr>
-                </a:tc>
-              </a:tr>
-            </a:tbl>
-          </a:graphicData>
-        </a:graphic>
-      </p:graphicFrame>
-      <p:sp>
-        <p:nvSpPr>
-          <p:cNvPr id="19" name="Rounded Rectangle 18"/>
+              <a:rPr sz="869" b="0" i="0">
+                <a:solidFill>
+                  <a:srgbClr val="142640"/>
+                </a:solidFill>
+                <a:latin typeface="Calibri"/>
+              </a:rPr>
+              <a:t>Supervisor + agentes especialistas</a:t>
+            </a:r>
+          </a:p>
+        </p:txBody>
+      </p:sp>
+      <p:sp>
+        <p:nvSpPr>
+          <p:cNvPr id="28" name="Rounded Rectangle 27"/>
           <p:cNvSpPr/>
           <p:nvPr/>
         </p:nvSpPr>
         <p:spPr>
           <a:xfrm>
-            <a:off x="502920" y="5623560"/>
-            <a:ext cx="5532120" cy="822960"/>
+            <a:off x="3319272" y="3913632"/>
+            <a:ext cx="2743200" cy="749808"/>
           </a:xfrm>
           <a:prstGeom prst="roundRect">
             <a:avLst>
@@ -18508,7 +17191,385 @@
           <a:solidFill>
             <a:srgbClr val="F2F2F2"/>
           </a:solidFill>
-          <a:ln w="13970">
+          <a:ln w="12700">
+            <a:solidFill>
+              <a:srgbClr val="1E8A4C"/>
+            </a:solidFill>
+          </a:ln>
+          <a:effectLst/>
+        </p:spPr>
+        <p:style>
+          <a:lnRef idx="1">
+            <a:schemeClr val="accent1"/>
+          </a:lnRef>
+          <a:fillRef idx="3">
+            <a:schemeClr val="accent1"/>
+          </a:fillRef>
+          <a:effectRef idx="2">
+            <a:schemeClr val="accent1"/>
+          </a:effectRef>
+          <a:fontRef idx="minor">
+            <a:schemeClr val="lt1"/>
+          </a:fontRef>
+        </p:style>
+        <p:txBody>
+          <a:bodyPr rtlCol="0" anchor="ctr"/>
+          <a:lstStyle/>
+          <a:p>
+            <a:pPr algn="ctr"/>
+          </a:p>
+        </p:txBody>
+      </p:sp>
+      <p:sp>
+        <p:nvSpPr>
+          <p:cNvPr id="29" name="TextBox 28"/>
+          <p:cNvSpPr txBox="1"/>
+          <p:nvPr/>
+        </p:nvSpPr>
+        <p:spPr>
+          <a:xfrm>
+            <a:off x="3429000" y="3959352"/>
+            <a:ext cx="2523744" cy="237744"/>
+          </a:xfrm>
+          <a:prstGeom prst="rect">
+            <a:avLst/>
+          </a:prstGeom>
+          <a:noFill/>
+        </p:spPr>
+        <p:txBody>
+          <a:bodyPr wrap="square" anchor="t" lIns="50800" rIns="50800" tIns="25400" bIns="25400">
+            <a:spAutoFit/>
+          </a:bodyPr>
+          <a:lstStyle/>
+          <a:p>
+            <a:pPr algn="l">
+              <a:lnSpc>
+                <a:spcPct val="100000"/>
+              </a:lnSpc>
+            </a:pPr>
+            <a:r>
+              <a:rPr sz="1050" b="1" i="0">
+                <a:solidFill>
+                  <a:srgbClr val="1E8A4C"/>
+                </a:solidFill>
+                <a:latin typeface="Calibri"/>
+              </a:rPr>
+              <a:t>✓ Planner–Executor</a:t>
+            </a:r>
+          </a:p>
+        </p:txBody>
+      </p:sp>
+      <p:sp>
+        <p:nvSpPr>
+          <p:cNvPr id="30" name="TextBox 29"/>
+          <p:cNvSpPr txBox="1"/>
+          <p:nvPr/>
+        </p:nvSpPr>
+        <p:spPr>
+          <a:xfrm>
+            <a:off x="3429000" y="4206240"/>
+            <a:ext cx="2523744" cy="420624"/>
+          </a:xfrm>
+          <a:prstGeom prst="rect">
+            <a:avLst/>
+          </a:prstGeom>
+          <a:noFill/>
+        </p:spPr>
+        <p:txBody>
+          <a:bodyPr wrap="square" anchor="t" lIns="50800" rIns="50800" tIns="25400" bIns="25400">
+            <a:spAutoFit/>
+          </a:bodyPr>
+          <a:lstStyle/>
+          <a:p>
+            <a:pPr algn="l">
+              <a:lnSpc>
+                <a:spcPct val="100000"/>
+              </a:lnSpc>
+            </a:pPr>
+            <a:r>
+              <a:rPr sz="869" b="0" i="0">
+                <a:solidFill>
+                  <a:srgbClr val="142640"/>
+                </a:solidFill>
+                <a:latin typeface="Calibri"/>
+              </a:rPr>
+              <a:t>Supervisor enruta; cada agente ejecuta</a:t>
+            </a:r>
+          </a:p>
+        </p:txBody>
+      </p:sp>
+      <p:sp>
+        <p:nvSpPr>
+          <p:cNvPr id="31" name="Rounded Rectangle 30"/>
+          <p:cNvSpPr/>
+          <p:nvPr/>
+        </p:nvSpPr>
+        <p:spPr>
+          <a:xfrm>
+            <a:off x="6135624" y="3913632"/>
+            <a:ext cx="2743200" cy="749808"/>
+          </a:xfrm>
+          <a:prstGeom prst="roundRect">
+            <a:avLst>
+              <a:gd name="adj" fmla="val 6000"/>
+            </a:avLst>
+          </a:prstGeom>
+          <a:solidFill>
+            <a:srgbClr val="F2F2F2"/>
+          </a:solidFill>
+          <a:ln w="12700">
+            <a:solidFill>
+              <a:srgbClr val="1E8A4C"/>
+            </a:solidFill>
+          </a:ln>
+          <a:effectLst/>
+        </p:spPr>
+        <p:style>
+          <a:lnRef idx="1">
+            <a:schemeClr val="accent1"/>
+          </a:lnRef>
+          <a:fillRef idx="3">
+            <a:schemeClr val="accent1"/>
+          </a:fillRef>
+          <a:effectRef idx="2">
+            <a:schemeClr val="accent1"/>
+          </a:effectRef>
+          <a:fontRef idx="minor">
+            <a:schemeClr val="lt1"/>
+          </a:fontRef>
+        </p:style>
+        <p:txBody>
+          <a:bodyPr rtlCol="0" anchor="ctr"/>
+          <a:lstStyle/>
+          <a:p>
+            <a:pPr algn="ctr"/>
+          </a:p>
+        </p:txBody>
+      </p:sp>
+      <p:sp>
+        <p:nvSpPr>
+          <p:cNvPr id="32" name="TextBox 31"/>
+          <p:cNvSpPr txBox="1"/>
+          <p:nvPr/>
+        </p:nvSpPr>
+        <p:spPr>
+          <a:xfrm>
+            <a:off x="6245352" y="3959352"/>
+            <a:ext cx="2523744" cy="237744"/>
+          </a:xfrm>
+          <a:prstGeom prst="rect">
+            <a:avLst/>
+          </a:prstGeom>
+          <a:noFill/>
+        </p:spPr>
+        <p:txBody>
+          <a:bodyPr wrap="square" anchor="t" lIns="50800" rIns="50800" tIns="25400" bIns="25400">
+            <a:spAutoFit/>
+          </a:bodyPr>
+          <a:lstStyle/>
+          <a:p>
+            <a:pPr algn="l">
+              <a:lnSpc>
+                <a:spcPct val="100000"/>
+              </a:lnSpc>
+            </a:pPr>
+            <a:r>
+              <a:rPr sz="1050" b="1" i="0">
+                <a:solidFill>
+                  <a:srgbClr val="1E8A4C"/>
+                </a:solidFill>
+                <a:latin typeface="Calibri"/>
+              </a:rPr>
+              <a:t>✓ Memory</a:t>
+            </a:r>
+          </a:p>
+        </p:txBody>
+      </p:sp>
+      <p:sp>
+        <p:nvSpPr>
+          <p:cNvPr id="33" name="TextBox 32"/>
+          <p:cNvSpPr txBox="1"/>
+          <p:nvPr/>
+        </p:nvSpPr>
+        <p:spPr>
+          <a:xfrm>
+            <a:off x="6245352" y="4206240"/>
+            <a:ext cx="2523744" cy="420624"/>
+          </a:xfrm>
+          <a:prstGeom prst="rect">
+            <a:avLst/>
+          </a:prstGeom>
+          <a:noFill/>
+        </p:spPr>
+        <p:txBody>
+          <a:bodyPr wrap="square" anchor="t" lIns="50800" rIns="50800" tIns="25400" bIns="25400">
+            <a:spAutoFit/>
+          </a:bodyPr>
+          <a:lstStyle/>
+          <a:p>
+            <a:pPr algn="l">
+              <a:lnSpc>
+                <a:spcPct val="100000"/>
+              </a:lnSpc>
+            </a:pPr>
+            <a:r>
+              <a:rPr sz="869" b="0" i="0">
+                <a:solidFill>
+                  <a:srgbClr val="142640"/>
+                </a:solidFill>
+                <a:latin typeface="Calibri"/>
+              </a:rPr>
+              <a:t>Memoria conversacional / Cosmos DB</a:t>
+            </a:r>
+          </a:p>
+        </p:txBody>
+      </p:sp>
+      <p:sp>
+        <p:nvSpPr>
+          <p:cNvPr id="34" name="Rounded Rectangle 33"/>
+          <p:cNvSpPr/>
+          <p:nvPr/>
+        </p:nvSpPr>
+        <p:spPr>
+          <a:xfrm>
+            <a:off x="8951976" y="3913632"/>
+            <a:ext cx="2743200" cy="749808"/>
+          </a:xfrm>
+          <a:prstGeom prst="roundRect">
+            <a:avLst>
+              <a:gd name="adj" fmla="val 6000"/>
+            </a:avLst>
+          </a:prstGeom>
+          <a:solidFill>
+            <a:srgbClr val="F2F2F2"/>
+          </a:solidFill>
+          <a:ln w="12700">
+            <a:solidFill>
+              <a:srgbClr val="1E8A4C"/>
+            </a:solidFill>
+          </a:ln>
+          <a:effectLst/>
+        </p:spPr>
+        <p:style>
+          <a:lnRef idx="1">
+            <a:schemeClr val="accent1"/>
+          </a:lnRef>
+          <a:fillRef idx="3">
+            <a:schemeClr val="accent1"/>
+          </a:fillRef>
+          <a:effectRef idx="2">
+            <a:schemeClr val="accent1"/>
+          </a:effectRef>
+          <a:fontRef idx="minor">
+            <a:schemeClr val="lt1"/>
+          </a:fontRef>
+        </p:style>
+        <p:txBody>
+          <a:bodyPr rtlCol="0" anchor="ctr"/>
+          <a:lstStyle/>
+          <a:p>
+            <a:pPr algn="ctr"/>
+          </a:p>
+        </p:txBody>
+      </p:sp>
+      <p:sp>
+        <p:nvSpPr>
+          <p:cNvPr id="35" name="TextBox 34"/>
+          <p:cNvSpPr txBox="1"/>
+          <p:nvPr/>
+        </p:nvSpPr>
+        <p:spPr>
+          <a:xfrm>
+            <a:off x="9061704" y="3959352"/>
+            <a:ext cx="2523744" cy="237744"/>
+          </a:xfrm>
+          <a:prstGeom prst="rect">
+            <a:avLst/>
+          </a:prstGeom>
+          <a:noFill/>
+        </p:spPr>
+        <p:txBody>
+          <a:bodyPr wrap="square" anchor="t" lIns="50800" rIns="50800" tIns="25400" bIns="25400">
+            <a:spAutoFit/>
+          </a:bodyPr>
+          <a:lstStyle/>
+          <a:p>
+            <a:pPr algn="l">
+              <a:lnSpc>
+                <a:spcPct val="100000"/>
+              </a:lnSpc>
+            </a:pPr>
+            <a:r>
+              <a:rPr sz="1050" b="1" i="0">
+                <a:solidFill>
+                  <a:srgbClr val="1E8A4C"/>
+                </a:solidFill>
+                <a:latin typeface="Calibri"/>
+              </a:rPr>
+              <a:t>✓ Guardrails</a:t>
+            </a:r>
+          </a:p>
+        </p:txBody>
+      </p:sp>
+      <p:sp>
+        <p:nvSpPr>
+          <p:cNvPr id="36" name="TextBox 35"/>
+          <p:cNvSpPr txBox="1"/>
+          <p:nvPr/>
+        </p:nvSpPr>
+        <p:spPr>
+          <a:xfrm>
+            <a:off x="9061704" y="4206240"/>
+            <a:ext cx="2523744" cy="420624"/>
+          </a:xfrm>
+          <a:prstGeom prst="rect">
+            <a:avLst/>
+          </a:prstGeom>
+          <a:noFill/>
+        </p:spPr>
+        <p:txBody>
+          <a:bodyPr wrap="square" anchor="t" lIns="50800" rIns="50800" tIns="25400" bIns="25400">
+            <a:spAutoFit/>
+          </a:bodyPr>
+          <a:lstStyle/>
+          <a:p>
+            <a:pPr algn="l">
+              <a:lnSpc>
+                <a:spcPct val="100000"/>
+              </a:lnSpc>
+            </a:pPr>
+            <a:r>
+              <a:rPr sz="869" b="0" i="0">
+                <a:solidFill>
+                  <a:srgbClr val="142640"/>
+                </a:solidFill>
+                <a:latin typeface="Calibri"/>
+              </a:rPr>
+              <a:t>Entra ID + JWT/JWKS + Tools deterministas</a:t>
+            </a:r>
+          </a:p>
+        </p:txBody>
+      </p:sp>
+      <p:sp>
+        <p:nvSpPr>
+          <p:cNvPr id="37" name="Rounded Rectangle 36"/>
+          <p:cNvSpPr/>
+          <p:nvPr/>
+        </p:nvSpPr>
+        <p:spPr>
+          <a:xfrm>
+            <a:off x="502920" y="4773168"/>
+            <a:ext cx="11201400" cy="566928"/>
+          </a:xfrm>
+          <a:prstGeom prst="roundRect">
+            <a:avLst>
+              <a:gd name="adj" fmla="val 6000"/>
+            </a:avLst>
+          </a:prstGeom>
+          <a:solidFill>
+            <a:srgbClr val="F2F2F2"/>
+          </a:solidFill>
+          <a:ln w="12700">
             <a:solidFill>
               <a:srgbClr val="B87A00"/>
             </a:solidFill>
@@ -18539,14 +17600,14 @@
       </p:sp>
       <p:sp>
         <p:nvSpPr>
-          <p:cNvPr id="20" name="TextBox 19"/>
+          <p:cNvPr id="38" name="TextBox 37"/>
           <p:cNvSpPr txBox="1"/>
           <p:nvPr/>
         </p:nvSpPr>
         <p:spPr>
           <a:xfrm>
-            <a:off x="685800" y="5687568"/>
-            <a:ext cx="5166360" cy="256032"/>
+            <a:off x="685800" y="4818888"/>
+            <a:ext cx="1828800" cy="219456"/>
           </a:xfrm>
           <a:prstGeom prst="rect">
             <a:avLst/>
@@ -18571,21 +17632,21 @@
                 </a:solidFill>
                 <a:latin typeface="Calibri"/>
               </a:rPr>
-              <a:t>EVOLUCIÓN FUTURA (no implementada)</a:t>
-            </a:r>
-          </a:p>
-        </p:txBody>
-      </p:sp>
-      <p:sp>
-        <p:nvSpPr>
-          <p:cNvPr id="21" name="TextBox 20"/>
+              <a:t>RAG</a:t>
+            </a:r>
+          </a:p>
+        </p:txBody>
+      </p:sp>
+      <p:sp>
+        <p:nvSpPr>
+          <p:cNvPr id="39" name="TextBox 38"/>
           <p:cNvSpPr txBox="1"/>
           <p:nvPr/>
         </p:nvSpPr>
         <p:spPr>
           <a:xfrm>
-            <a:off x="685800" y="5943600"/>
-            <a:ext cx="5166360" cy="457200"/>
+            <a:off x="2194560" y="4818888"/>
+            <a:ext cx="9326880" cy="457200"/>
           </a:xfrm>
           <a:prstGeom prst="rect">
             <a:avLst/>
@@ -18604,27 +17665,154 @@
               </a:lnSpc>
             </a:pPr>
             <a:r>
-              <a:rPr sz="1000" b="0" i="0">
+              <a:rPr sz="930" b="0" i="0">
                 <a:solidFill>
                   <a:srgbClr val="142640"/>
                 </a:solidFill>
                 <a:latin typeface="Calibri"/>
               </a:rPr>
-              <a:t>LLM-as-a-Judge · Self-Reflection — evaluarían o corregirían el razonamiento del propio agente; ReAct ya no está en esta lista: es el patrón primario implementado.</a:t>
-            </a:r>
-          </a:p>
-        </p:txBody>
-      </p:sp>
-      <p:sp>
-        <p:nvSpPr>
-          <p:cNvPr id="22" name="Rounded Rectangle 21"/>
+              <a:t>Azure AI Search: arquitectura disponible para fundamentar respuestas en documentación empresarial. Uso actual limitado a datos sintéticos — sin exagerar el alcance.</a:t>
+            </a:r>
+          </a:p>
+        </p:txBody>
+      </p:sp>
+      <p:sp>
+        <p:nvSpPr>
+          <p:cNvPr id="40" name="Rounded Rectangle 39"/>
           <p:cNvSpPr/>
           <p:nvPr/>
         </p:nvSpPr>
         <p:spPr>
           <a:xfrm>
-            <a:off x="6172200" y="5623560"/>
-            <a:ext cx="5532120" cy="822960"/>
+            <a:off x="502920" y="5468112"/>
+            <a:ext cx="5532120" cy="960120"/>
+          </a:xfrm>
+          <a:prstGeom prst="roundRect">
+            <a:avLst>
+              <a:gd name="adj" fmla="val 6000"/>
+            </a:avLst>
+          </a:prstGeom>
+          <a:solidFill>
+            <a:srgbClr val="F2F2F2"/>
+          </a:solidFill>
+          <a:ln w="12700">
+            <a:solidFill>
+              <a:srgbClr val="8A8A8A"/>
+            </a:solidFill>
+            <a:prstDash val="dash"/>
+          </a:ln>
+          <a:effectLst/>
+        </p:spPr>
+        <p:style>
+          <a:lnRef idx="1">
+            <a:schemeClr val="accent1"/>
+          </a:lnRef>
+          <a:fillRef idx="3">
+            <a:schemeClr val="accent1"/>
+          </a:fillRef>
+          <a:effectRef idx="2">
+            <a:schemeClr val="accent1"/>
+          </a:effectRef>
+          <a:fontRef idx="minor">
+            <a:schemeClr val="lt1"/>
+          </a:fontRef>
+        </p:style>
+        <p:txBody>
+          <a:bodyPr rtlCol="0" anchor="ctr"/>
+          <a:lstStyle/>
+          <a:p>
+            <a:pPr algn="ctr"/>
+          </a:p>
+        </p:txBody>
+      </p:sp>
+      <p:sp>
+        <p:nvSpPr>
+          <p:cNvPr id="41" name="TextBox 40"/>
+          <p:cNvSpPr txBox="1"/>
+          <p:nvPr/>
+        </p:nvSpPr>
+        <p:spPr>
+          <a:xfrm>
+            <a:off x="685800" y="5532120"/>
+            <a:ext cx="5166360" cy="237744"/>
+          </a:xfrm>
+          <a:prstGeom prst="rect">
+            <a:avLst/>
+          </a:prstGeom>
+          <a:noFill/>
+        </p:spPr>
+        <p:txBody>
+          <a:bodyPr wrap="square" anchor="t" lIns="50800" rIns="50800" tIns="25400" bIns="25400">
+            <a:spAutoFit/>
+          </a:bodyPr>
+          <a:lstStyle/>
+          <a:p>
+            <a:pPr algn="l">
+              <a:lnSpc>
+                <a:spcPct val="100000"/>
+              </a:lnSpc>
+            </a:pPr>
+            <a:r>
+              <a:rPr sz="1000" b="1" i="0">
+                <a:solidFill>
+                  <a:srgbClr val="555555"/>
+                </a:solidFill>
+                <a:latin typeface="Calibri"/>
+              </a:rPr>
+              <a:t>EVOLUCIÓN FUTURA (no implementada)</a:t>
+            </a:r>
+          </a:p>
+        </p:txBody>
+      </p:sp>
+      <p:sp>
+        <p:nvSpPr>
+          <p:cNvPr id="42" name="TextBox 41"/>
+          <p:cNvSpPr txBox="1"/>
+          <p:nvPr/>
+        </p:nvSpPr>
+        <p:spPr>
+          <a:xfrm>
+            <a:off x="685800" y="5788152"/>
+            <a:ext cx="5166360" cy="594360"/>
+          </a:xfrm>
+          <a:prstGeom prst="rect">
+            <a:avLst/>
+          </a:prstGeom>
+          <a:noFill/>
+        </p:spPr>
+        <p:txBody>
+          <a:bodyPr wrap="square" anchor="t" lIns="50800" rIns="50800" tIns="25400" bIns="25400">
+            <a:spAutoFit/>
+          </a:bodyPr>
+          <a:lstStyle/>
+          <a:p>
+            <a:pPr algn="l">
+              <a:lnSpc>
+                <a:spcPct val="100000"/>
+              </a:lnSpc>
+            </a:pPr>
+            <a:r>
+              <a:rPr sz="930" b="0" i="0">
+                <a:solidFill>
+                  <a:srgbClr val="142640"/>
+                </a:solidFill>
+                <a:latin typeface="Calibri"/>
+              </a:rPr>
+              <a:t>LLM-as-a-Judge · Self-Reflection — ReAct ya no pertenece a esta lista: es el patrón principal implementado en los tres agentes.</a:t>
+            </a:r>
+          </a:p>
+        </p:txBody>
+      </p:sp>
+      <p:sp>
+        <p:nvSpPr>
+          <p:cNvPr id="43" name="Rounded Rectangle 42"/>
+          <p:cNvSpPr/>
+          <p:nvPr/>
+        </p:nvSpPr>
+        <p:spPr>
+          <a:xfrm>
+            <a:off x="6172200" y="5468112"/>
+            <a:ext cx="5532120" cy="960120"/>
           </a:xfrm>
           <a:prstGeom prst="roundRect">
             <a:avLst>
@@ -18663,14 +17851,14 @@
       </p:sp>
       <p:sp>
         <p:nvSpPr>
-          <p:cNvPr id="23" name="TextBox 22"/>
+          <p:cNvPr id="44" name="TextBox 43"/>
           <p:cNvSpPr txBox="1"/>
           <p:nvPr/>
         </p:nvSpPr>
         <p:spPr>
           <a:xfrm>
-            <a:off x="6355080" y="5687568"/>
-            <a:ext cx="5166360" cy="256032"/>
+            <a:off x="6355080" y="5532120"/>
+            <a:ext cx="5166360" cy="237744"/>
           </a:xfrm>
           <a:prstGeom prst="rect">
             <a:avLst/>
@@ -18689,7 +17877,7 @@
               </a:lnSpc>
             </a:pPr>
             <a:r>
-              <a:rPr sz="1050" b="1" i="0">
+              <a:rPr sz="1000" b="1" i="0">
                 <a:solidFill>
                   <a:srgbClr val="9FC1E0"/>
                 </a:solidFill>
@@ -18702,14 +17890,14 @@
       </p:sp>
       <p:sp>
         <p:nvSpPr>
-          <p:cNvPr id="24" name="TextBox 23"/>
+          <p:cNvPr id="45" name="TextBox 44"/>
           <p:cNvSpPr txBox="1"/>
           <p:nvPr/>
         </p:nvSpPr>
         <p:spPr>
           <a:xfrm>
-            <a:off x="6355080" y="5943600"/>
-            <a:ext cx="5166360" cy="457200"/>
+            <a:off x="6355080" y="5788152"/>
+            <a:ext cx="5166360" cy="594360"/>
           </a:xfrm>
           <a:prstGeom prst="rect">
             <a:avLst/>
@@ -18728,13 +17916,13 @@
               </a:lnSpc>
             </a:pPr>
             <a:r>
-              <a:rPr sz="1000" b="0" i="0">
+              <a:rPr sz="930" b="0" i="0">
                 <a:solidFill>
                   <a:srgbClr val="FFFFFF"/>
                 </a:solidFill>
                 <a:latin typeface="Calibri"/>
               </a:rPr>
-              <a:t>El razonamiento interno del bucle ReAct nunca se expone ni se persiste — solo la respuesta final llega al usuario o al historial (CLAUDE.md §10).</a:t>
+              <a:t>El razonamiento interno del bucle ReAct nunca se expone al usuario ni se persiste — solo la respuesta final (CLAUDE.md §10).</a:t>
             </a:r>
           </a:p>
         </p:txBody>

</xml_diff>